<commit_message>
chore(release): 版本 bump 至 v1.5.2
- __version__ 1.5.1 -> 1.5.2（Windows/ deb 双安装包版本源头）
- README/结构说明/落地方案 同步 v1.5.2
- setup_windows.iss 本地兜底版本 1.5.0 -> 1.5.2
- 介绍 PPT 重新生成（v1.5.2 终验零残留）
</commit_message>
<xml_diff>
--- a/公文汇编助手-系统介绍.pptx
+++ b/公文汇编助手-系统介绍.pptx
@@ -4440,7 +4440,7 @@
                 <a:ea typeface="Microsoft YaHei" pitchFamily="34" charset="-122"/>
                 <a:cs typeface="Microsoft YaHei" pitchFamily="34" charset="-120"/>
               </a:rPr>
-              <a:t>GWTOOL · 单机离线版 v1.5.1</a:t>
+              <a:t>GWTOOL · 单机离线版 v1.5.2</a:t>
             </a:r>
             <a:endParaRPr lang="en-US" sz="1300" dirty="0"/>
           </a:p>
@@ -38796,7 +38796,7 @@
                 <a:ea typeface="Microsoft YaHei" pitchFamily="34" charset="-122"/>
                 <a:cs typeface="Microsoft YaHei" pitchFamily="34" charset="-120"/>
               </a:rPr>
-              <a:t>公文汇编助手 · 单机离线版 v1.5.1</a:t>
+              <a:t>公文汇编助手 · 单机离线版 v1.5.2</a:t>
             </a:r>
             <a:endParaRPr lang="en-US" sz="1200" dirty="0"/>
           </a:p>

</xml_diff>

<commit_message>
fix(quality): open-code-review 全项目审查修复 12 处缺陷 + 隐私加固 + 文档与 PPT 同步
工具 alibaba/open-code-review v1.12.5，扫描 161 文件 / 39,358 行。
内置 LLM 密钥余额不足（402），改用其官方 delegate 模式（工具出规则集）。

候选 2368 → 生产代码 82 → 确认缺陷 12 / 合理降级 62 / 误报 8。

12 条共同特征：失败被吞掉，代码却仍做出成功的承诺。
- backup.py ×3：新增 RestoreReport.warnings，恢复前自动备份失败/模板回写失败/
  附件还原失败从静默改为 UI 点名（附件那条最重：原失败被吞成 restored=0 而报告仍 ok=True）
- batch.py / feature_dialogs.py ×2：快照失败仍继续改，但写入 failures
- exporter.py / enhance_pack.py / csc_gec.py / reminder.py / dbhealth.py 等 ×7：加日志留痕
62 处确认为刻意的静默降级，按规则集要求保持原样。

隐私加固：redact() 原先全仓 0 调用，诊断包把整份原始日志塞进 zip 而 UI 承诺
不含正文。现改为日志入队前脱敏 + 崩溃摘要只留类型/长度/位置 + 诊断包兜底脱敏，
并新增 tests/test_logs_privacy.py 把承诺变成断言。

文档与 PPT：新增 open-code-review审查报告.md；修正项目文件结构说明的多处失实
（版本号/已删样张/测试数/ruff 描述）；README 测试数 1118→1127；PPT 重建 43 页。

验证：pytest 1127 passed / 3 skipped / 0 failed；ruff All checks passed；
e2e 20 项通过。版本号保持 1.6.0。
</commit_message>
<xml_diff>
--- a/公文汇编助手-系统介绍.pptx
+++ b/公文汇编助手-系统介绍.pptx
@@ -46,9 +46,11 @@
     <p:sldId id="294" r:id="rId40"/>
     <p:sldId id="295" r:id="rId41"/>
     <p:sldId id="296" r:id="rId42"/>
+    <p:sldId id="297" r:id="rId43"/>
+    <p:sldId id="298" r:id="rId44"/>
   </p:sldIdLst>
   <p:notesMasterIdLst>
-    <p:notesMasterId r:id="rId43"/>
+    <p:notesMasterId r:id="rId45"/>
   </p:notesMasterIdLst>
   <p:sldSz cx="12192000" cy="6858000"/>
   <p:notesSz cx="6858000" cy="12192000"/>
@@ -3646,6 +3648,182 @@
             <a:fld id="{F7021451-1387-4CA6-816F-3879F97B5CBC}" type="slidenum">
               <a:rPr lang="en-US"/>
               <a:t>41</a:t>
+            </a:fld>
+            <a:endParaRPr lang="en-US"/>
+          </a:p>
+        </p:txBody>
+      </p:sp>
+    </p:spTree>
+    <p:extLst>
+      <p:ext uri="{BB962C8B-B14F-4D97-AF65-F5344CB8AC3E}">
+        <p14:creationId xmlns:p14="http://schemas.microsoft.com/office/powerpoint/2010/main" val="1024086991"/>
+      </p:ext>
+    </p:extLst>
+  </p:cSld>
+  <p:clrMapOvr>
+    <a:masterClrMapping/>
+  </p:clrMapOvr>
+</p:notes>
+</file>
+
+<file path=ppt/notesSlides/notesSlide42.xml><?xml version="1.0" encoding="utf-8"?>
+<p:notes xmlns:a="http://schemas.openxmlformats.org/drawingml/2006/main" xmlns:r="http://schemas.openxmlformats.org/officeDocument/2006/relationships" xmlns:p="http://schemas.openxmlformats.org/presentationml/2006/main">
+  <p:cSld>
+    <p:spTree>
+      <p:nvGrpSpPr>
+        <p:cNvPr id="1" name=""/>
+        <p:cNvGrpSpPr/>
+        <p:nvPr/>
+      </p:nvGrpSpPr>
+      <p:grpSpPr>
+        <a:xfrm>
+          <a:off x="0" y="0"/>
+          <a:ext cx="0" cy="0"/>
+          <a:chOff x="0" y="0"/>
+          <a:chExt cx="0" cy="0"/>
+        </a:xfrm>
+      </p:grpSpPr>
+      <p:sp>
+        <p:nvSpPr>
+          <p:cNvPr id="2" name="Slide Image Placeholder 1"/>
+          <p:cNvSpPr>
+            <a:spLocks noGrp="1" noRot="1" noChangeAspect="1"/>
+          </p:cNvSpPr>
+          <p:nvPr>
+            <p:ph type="sldImg"/>
+          </p:nvPr>
+        </p:nvSpPr>
+        <p:spPr/>
+      </p:sp>
+      <p:sp>
+        <p:nvSpPr>
+          <p:cNvPr id="3" name="Notes Placeholder 2"/>
+          <p:cNvSpPr>
+            <a:spLocks noGrp="1"/>
+          </p:cNvSpPr>
+          <p:nvPr>
+            <p:ph type="body" idx="1"/>
+          </p:nvPr>
+        </p:nvSpPr>
+        <p:spPr/>
+        <p:txBody>
+          <a:bodyPr/>
+          <a:lstStyle/>
+          <a:p>
+            <a:r>
+              <a:rPr lang="en-US" dirty="0"/>
+              <a:t/>
+            </a:r>
+            <a:endParaRPr lang="en-US" dirty="0"/>
+          </a:p>
+        </p:txBody>
+      </p:sp>
+      <p:sp>
+        <p:nvSpPr>
+          <p:cNvPr id="4" name="Slide Number Placeholder 3"/>
+          <p:cNvSpPr>
+            <a:spLocks noGrp="1"/>
+          </p:cNvSpPr>
+          <p:nvPr>
+            <p:ph type="sldNum" sz="quarter" idx="10"/>
+          </p:nvPr>
+        </p:nvSpPr>
+        <p:spPr/>
+        <p:txBody>
+          <a:bodyPr/>
+          <a:lstStyle/>
+          <a:p>
+            <a:fld id="{F7021451-1387-4CA6-816F-3879F97B5CBC}" type="slidenum">
+              <a:rPr lang="en-US"/>
+              <a:t>42</a:t>
+            </a:fld>
+            <a:endParaRPr lang="en-US"/>
+          </a:p>
+        </p:txBody>
+      </p:sp>
+    </p:spTree>
+    <p:extLst>
+      <p:ext uri="{BB962C8B-B14F-4D97-AF65-F5344CB8AC3E}">
+        <p14:creationId xmlns:p14="http://schemas.microsoft.com/office/powerpoint/2010/main" val="1024086991"/>
+      </p:ext>
+    </p:extLst>
+  </p:cSld>
+  <p:clrMapOvr>
+    <a:masterClrMapping/>
+  </p:clrMapOvr>
+</p:notes>
+</file>
+
+<file path=ppt/notesSlides/notesSlide43.xml><?xml version="1.0" encoding="utf-8"?>
+<p:notes xmlns:a="http://schemas.openxmlformats.org/drawingml/2006/main" xmlns:r="http://schemas.openxmlformats.org/officeDocument/2006/relationships" xmlns:p="http://schemas.openxmlformats.org/presentationml/2006/main">
+  <p:cSld>
+    <p:spTree>
+      <p:nvGrpSpPr>
+        <p:cNvPr id="1" name=""/>
+        <p:cNvGrpSpPr/>
+        <p:nvPr/>
+      </p:nvGrpSpPr>
+      <p:grpSpPr>
+        <a:xfrm>
+          <a:off x="0" y="0"/>
+          <a:ext cx="0" cy="0"/>
+          <a:chOff x="0" y="0"/>
+          <a:chExt cx="0" cy="0"/>
+        </a:xfrm>
+      </p:grpSpPr>
+      <p:sp>
+        <p:nvSpPr>
+          <p:cNvPr id="2" name="Slide Image Placeholder 1"/>
+          <p:cNvSpPr>
+            <a:spLocks noGrp="1" noRot="1" noChangeAspect="1"/>
+          </p:cNvSpPr>
+          <p:nvPr>
+            <p:ph type="sldImg"/>
+          </p:nvPr>
+        </p:nvSpPr>
+        <p:spPr/>
+      </p:sp>
+      <p:sp>
+        <p:nvSpPr>
+          <p:cNvPr id="3" name="Notes Placeholder 2"/>
+          <p:cNvSpPr>
+            <a:spLocks noGrp="1"/>
+          </p:cNvSpPr>
+          <p:nvPr>
+            <p:ph type="body" idx="1"/>
+          </p:nvPr>
+        </p:nvSpPr>
+        <p:spPr/>
+        <p:txBody>
+          <a:bodyPr/>
+          <a:lstStyle/>
+          <a:p>
+            <a:r>
+              <a:rPr lang="en-US" dirty="0"/>
+              <a:t/>
+            </a:r>
+            <a:endParaRPr lang="en-US" dirty="0"/>
+          </a:p>
+        </p:txBody>
+      </p:sp>
+      <p:sp>
+        <p:nvSpPr>
+          <p:cNvPr id="4" name="Slide Number Placeholder 3"/>
+          <p:cNvSpPr>
+            <a:spLocks noGrp="1"/>
+          </p:cNvSpPr>
+          <p:nvPr>
+            <p:ph type="sldNum" sz="quarter" idx="10"/>
+          </p:nvPr>
+        </p:nvSpPr>
+        <p:spPr/>
+        <p:txBody>
+          <a:bodyPr/>
+          <a:lstStyle/>
+          <a:p>
+            <a:fld id="{F7021451-1387-4CA6-816F-3879F97B5CBC}" type="slidenum">
+              <a:rPr lang="en-US"/>
+              <a:t>43</a:t>
             </a:fld>
             <a:endParaRPr lang="en-US"/>
           </a:p>
@@ -4805,7 +4983,7 @@
                 <a:ea typeface="Microsoft YaHei" pitchFamily="34" charset="-122"/>
                 <a:cs typeface="Microsoft YaHei" pitchFamily="34" charset="-120"/>
               </a:rPr>
-              <a:t>GB/T 9704 公文格式</a:t>
+              <a:t>GJB 5100A 军队公文格式</a:t>
             </a:r>
             <a:endParaRPr lang="en-US" sz="1250" dirty="0"/>
           </a:p>
@@ -4871,7 +5049,7 @@
                 <a:ea typeface="Microsoft YaHei" pitchFamily="34" charset="-122"/>
                 <a:cs typeface="Microsoft YaHei" pitchFamily="34" charset="-120"/>
               </a:rPr>
-              <a:t>1118 项自动化测试</a:t>
+              <a:t>1127 项自动化测试</a:t>
             </a:r>
             <a:endParaRPr lang="en-US" sz="1250" dirty="0"/>
           </a:p>
@@ -13523,7 +13701,7 @@
                 <a:ea typeface="Microsoft YaHei" pitchFamily="34" charset="-122"/>
                 <a:cs typeface="Microsoft YaHei" pitchFamily="34" charset="-120"/>
               </a:rPr>
-              <a:t>15 种法定文种骨架，填要素即成稿</a:t>
+              <a:t>12 种军队机关公文文种骨架，填要素即成稿</a:t>
             </a:r>
             <a:endParaRPr lang="en-US" sz="1350" dirty="0"/>
           </a:p>
@@ -13890,7 +14068,7 @@
                 <a:ea typeface="Microsoft YaHei" pitchFamily="34" charset="-122"/>
                 <a:cs typeface="Microsoft YaHei" pitchFamily="34" charset="-120"/>
               </a:rPr>
-              <a:t>新建公文：15 种法定文种骨架全覆盖</a:t>
+              <a:t>新建公文：12 种军队机关公文文种骨架全覆盖</a:t>
             </a:r>
             <a:endParaRPr lang="en-US" sz="2600" dirty="0"/>
           </a:p>
@@ -14048,7 +14226,7 @@
                 <a:ea typeface="Microsoft YaHei" pitchFamily="34" charset="-122"/>
                 <a:cs typeface="Microsoft YaHei" pitchFamily="34" charset="-120"/>
               </a:rPr>
-              <a:t>决议</a:t>
+              <a:t>命令</a:t>
             </a:r>
             <a:endParaRPr lang="en-US" sz="1100" dirty="0"/>
           </a:p>
@@ -14128,7 +14306,7 @@
                 <a:ea typeface="Microsoft YaHei" pitchFamily="34" charset="-122"/>
                 <a:cs typeface="Microsoft YaHei" pitchFamily="34" charset="-120"/>
               </a:rPr>
-              <a:t>决定</a:t>
+              <a:t>通令</a:t>
             </a:r>
             <a:endParaRPr lang="en-US" sz="1100" dirty="0"/>
           </a:p>
@@ -14208,7 +14386,7 @@
                 <a:ea typeface="Microsoft YaHei" pitchFamily="34" charset="-122"/>
                 <a:cs typeface="Microsoft YaHei" pitchFamily="34" charset="-120"/>
               </a:rPr>
-              <a:t>命令（令）</a:t>
+              <a:t>决定</a:t>
             </a:r>
             <a:endParaRPr lang="en-US" sz="1100" dirty="0"/>
           </a:p>
@@ -14288,7 +14466,7 @@
                 <a:ea typeface="Microsoft YaHei" pitchFamily="34" charset="-122"/>
                 <a:cs typeface="Microsoft YaHei" pitchFamily="34" charset="-120"/>
               </a:rPr>
-              <a:t>公报</a:t>
+              <a:t>指示</a:t>
             </a:r>
             <a:endParaRPr lang="en-US" sz="1100" dirty="0"/>
           </a:p>
@@ -14368,7 +14546,7 @@
                 <a:ea typeface="Microsoft YaHei" pitchFamily="34" charset="-122"/>
                 <a:cs typeface="Microsoft YaHei" pitchFamily="34" charset="-120"/>
               </a:rPr>
-              <a:t>公告</a:t>
+              <a:t>通知</a:t>
             </a:r>
             <a:endParaRPr lang="en-US" sz="1100" dirty="0"/>
           </a:p>
@@ -14448,7 +14626,7 @@
                 <a:ea typeface="Microsoft YaHei" pitchFamily="34" charset="-122"/>
                 <a:cs typeface="Microsoft YaHei" pitchFamily="34" charset="-120"/>
               </a:rPr>
-              <a:t>通告</a:t>
+              <a:t>通报</a:t>
             </a:r>
             <a:endParaRPr lang="en-US" sz="1100" dirty="0"/>
           </a:p>
@@ -14528,7 +14706,7 @@
                 <a:ea typeface="Microsoft YaHei" pitchFamily="34" charset="-122"/>
                 <a:cs typeface="Microsoft YaHei" pitchFamily="34" charset="-120"/>
               </a:rPr>
-              <a:t>意见</a:t>
+              <a:t>报告</a:t>
             </a:r>
             <a:endParaRPr lang="en-US" sz="1100" dirty="0"/>
           </a:p>
@@ -14608,7 +14786,7 @@
                 <a:ea typeface="Microsoft YaHei" pitchFamily="34" charset="-122"/>
                 <a:cs typeface="Microsoft YaHei" pitchFamily="34" charset="-120"/>
               </a:rPr>
-              <a:t>通知</a:t>
+              <a:t>请示</a:t>
             </a:r>
             <a:endParaRPr lang="en-US" sz="1100" dirty="0"/>
           </a:p>
@@ -14688,7 +14866,7 @@
                 <a:ea typeface="Microsoft YaHei" pitchFamily="34" charset="-122"/>
                 <a:cs typeface="Microsoft YaHei" pitchFamily="34" charset="-120"/>
               </a:rPr>
-              <a:t>通报</a:t>
+              <a:t>批复</a:t>
             </a:r>
             <a:endParaRPr lang="en-US" sz="1100" dirty="0"/>
           </a:p>
@@ -14768,7 +14946,7 @@
                 <a:ea typeface="Microsoft YaHei" pitchFamily="34" charset="-122"/>
                 <a:cs typeface="Microsoft YaHei" pitchFamily="34" charset="-120"/>
               </a:rPr>
-              <a:t>报告</a:t>
+              <a:t>函</a:t>
             </a:r>
             <a:endParaRPr lang="en-US" sz="1100" dirty="0"/>
           </a:p>
@@ -14848,7 +15026,7 @@
                 <a:ea typeface="Microsoft YaHei" pitchFamily="34" charset="-122"/>
                 <a:cs typeface="Microsoft YaHei" pitchFamily="34" charset="-120"/>
               </a:rPr>
-              <a:t>请示</a:t>
+              <a:t>通告</a:t>
             </a:r>
             <a:endParaRPr lang="en-US" sz="1100" dirty="0"/>
           </a:p>
@@ -14928,7 +15106,7 @@
                 <a:ea typeface="Microsoft YaHei" pitchFamily="34" charset="-122"/>
                 <a:cs typeface="Microsoft YaHei" pitchFamily="34" charset="-120"/>
               </a:rPr>
-              <a:t>批复</a:t>
+              <a:t>纪要</a:t>
             </a:r>
             <a:endParaRPr lang="en-US" sz="1100" dirty="0"/>
           </a:p>
@@ -14937,246 +15115,6 @@
       <p:sp>
         <p:nvSpPr>
           <p:cNvPr id="32" name="Shape 30"/>
-          <p:cNvSpPr/>
-          <p:nvPr/>
-        </p:nvSpPr>
-        <p:spPr>
-          <a:xfrm>
-            <a:off x="5029200" y="3337560"/>
-            <a:ext cx="2121408" cy="621792"/>
-          </a:xfrm>
-          <a:prstGeom prst="roundRect">
-            <a:avLst>
-              <a:gd name="adj" fmla="val 10294"/>
-            </a:avLst>
-          </a:prstGeom>
-          <a:solidFill>
-            <a:srgbClr val="F8F4EE"/>
-          </a:solidFill>
-          <a:ln w="12700">
-            <a:solidFill>
-              <a:srgbClr val="E7DFD5"/>
-            </a:solidFill>
-            <a:prstDash val="solid"/>
-          </a:ln>
-        </p:spPr>
-      </p:sp>
-      <p:sp>
-        <p:nvSpPr>
-          <p:cNvPr id="33" name="Text 31"/>
-          <p:cNvSpPr/>
-          <p:nvPr/>
-        </p:nvSpPr>
-        <p:spPr>
-          <a:xfrm>
-            <a:off x="5157216" y="3337560"/>
-            <a:ext cx="1920240" cy="621792"/>
-          </a:xfrm>
-          <a:prstGeom prst="rect">
-            <a:avLst/>
-          </a:prstGeom>
-          <a:noFill/>
-          <a:ln/>
-        </p:spPr>
-        <p:txBody>
-          <a:bodyPr wrap="square" lIns="0" tIns="0" rIns="0" bIns="0" rtlCol="0" anchor="ctr"/>
-          <a:lstStyle/>
-          <a:p>
-            <a:pPr indent="0" marL="0">
-              <a:buNone/>
-            </a:pPr>
-            <a:r>
-              <a:rPr lang="en-US" sz="1100" b="1" dirty="0">
-                <a:solidFill>
-                  <a:srgbClr val="C9A227"/>
-                </a:solidFill>
-                <a:latin typeface="Microsoft YaHei" pitchFamily="34" charset="0"/>
-                <a:ea typeface="Microsoft YaHei" pitchFamily="34" charset="-122"/>
-                <a:cs typeface="Microsoft YaHei" pitchFamily="34" charset="-120"/>
-              </a:rPr>
-              <a:t>13  </a:t>
-            </a:r>
-            <a:pPr indent="0" marL="0">
-              <a:buNone/>
-            </a:pPr>
-            <a:r>
-              <a:rPr lang="en-US" sz="1450" b="1" dirty="0">
-                <a:solidFill>
-                  <a:srgbClr val="26201C"/>
-                </a:solidFill>
-                <a:latin typeface="Microsoft YaHei" pitchFamily="34" charset="0"/>
-                <a:ea typeface="Microsoft YaHei" pitchFamily="34" charset="-122"/>
-                <a:cs typeface="Microsoft YaHei" pitchFamily="34" charset="-120"/>
-              </a:rPr>
-              <a:t>议案</a:t>
-            </a:r>
-            <a:endParaRPr lang="en-US" sz="1100" dirty="0"/>
-          </a:p>
-        </p:txBody>
-      </p:sp>
-      <p:sp>
-        <p:nvSpPr>
-          <p:cNvPr id="34" name="Shape 32"/>
-          <p:cNvSpPr/>
-          <p:nvPr/>
-        </p:nvSpPr>
-        <p:spPr>
-          <a:xfrm>
-            <a:off x="7315200" y="3337560"/>
-            <a:ext cx="2121408" cy="621792"/>
-          </a:xfrm>
-          <a:prstGeom prst="roundRect">
-            <a:avLst>
-              <a:gd name="adj" fmla="val 10294"/>
-            </a:avLst>
-          </a:prstGeom>
-          <a:solidFill>
-            <a:srgbClr val="F8F4EE"/>
-          </a:solidFill>
-          <a:ln w="12700">
-            <a:solidFill>
-              <a:srgbClr val="E7DFD5"/>
-            </a:solidFill>
-            <a:prstDash val="solid"/>
-          </a:ln>
-        </p:spPr>
-      </p:sp>
-      <p:sp>
-        <p:nvSpPr>
-          <p:cNvPr id="35" name="Text 33"/>
-          <p:cNvSpPr/>
-          <p:nvPr/>
-        </p:nvSpPr>
-        <p:spPr>
-          <a:xfrm>
-            <a:off x="7443216" y="3337560"/>
-            <a:ext cx="1920240" cy="621792"/>
-          </a:xfrm>
-          <a:prstGeom prst="rect">
-            <a:avLst/>
-          </a:prstGeom>
-          <a:noFill/>
-          <a:ln/>
-        </p:spPr>
-        <p:txBody>
-          <a:bodyPr wrap="square" lIns="0" tIns="0" rIns="0" bIns="0" rtlCol="0" anchor="ctr"/>
-          <a:lstStyle/>
-          <a:p>
-            <a:pPr indent="0" marL="0">
-              <a:buNone/>
-            </a:pPr>
-            <a:r>
-              <a:rPr lang="en-US" sz="1100" b="1" dirty="0">
-                <a:solidFill>
-                  <a:srgbClr val="C9A227"/>
-                </a:solidFill>
-                <a:latin typeface="Microsoft YaHei" pitchFamily="34" charset="0"/>
-                <a:ea typeface="Microsoft YaHei" pitchFamily="34" charset="-122"/>
-                <a:cs typeface="Microsoft YaHei" pitchFamily="34" charset="-120"/>
-              </a:rPr>
-              <a:t>14  </a:t>
-            </a:r>
-            <a:pPr indent="0" marL="0">
-              <a:buNone/>
-            </a:pPr>
-            <a:r>
-              <a:rPr lang="en-US" sz="1450" b="1" dirty="0">
-                <a:solidFill>
-                  <a:srgbClr val="26201C"/>
-                </a:solidFill>
-                <a:latin typeface="Microsoft YaHei" pitchFamily="34" charset="0"/>
-                <a:ea typeface="Microsoft YaHei" pitchFamily="34" charset="-122"/>
-                <a:cs typeface="Microsoft YaHei" pitchFamily="34" charset="-120"/>
-              </a:rPr>
-              <a:t>函</a:t>
-            </a:r>
-            <a:endParaRPr lang="en-US" sz="1100" dirty="0"/>
-          </a:p>
-        </p:txBody>
-      </p:sp>
-      <p:sp>
-        <p:nvSpPr>
-          <p:cNvPr id="36" name="Shape 34"/>
-          <p:cNvSpPr/>
-          <p:nvPr/>
-        </p:nvSpPr>
-        <p:spPr>
-          <a:xfrm>
-            <a:off x="9601200" y="3337560"/>
-            <a:ext cx="2121408" cy="621792"/>
-          </a:xfrm>
-          <a:prstGeom prst="roundRect">
-            <a:avLst>
-              <a:gd name="adj" fmla="val 10294"/>
-            </a:avLst>
-          </a:prstGeom>
-          <a:solidFill>
-            <a:srgbClr val="F8F4EE"/>
-          </a:solidFill>
-          <a:ln w="12700">
-            <a:solidFill>
-              <a:srgbClr val="E7DFD5"/>
-            </a:solidFill>
-            <a:prstDash val="solid"/>
-          </a:ln>
-        </p:spPr>
-      </p:sp>
-      <p:sp>
-        <p:nvSpPr>
-          <p:cNvPr id="37" name="Text 35"/>
-          <p:cNvSpPr/>
-          <p:nvPr/>
-        </p:nvSpPr>
-        <p:spPr>
-          <a:xfrm>
-            <a:off x="9729216" y="3337560"/>
-            <a:ext cx="1920240" cy="621792"/>
-          </a:xfrm>
-          <a:prstGeom prst="rect">
-            <a:avLst/>
-          </a:prstGeom>
-          <a:noFill/>
-          <a:ln/>
-        </p:spPr>
-        <p:txBody>
-          <a:bodyPr wrap="square" lIns="0" tIns="0" rIns="0" bIns="0" rtlCol="0" anchor="ctr"/>
-          <a:lstStyle/>
-          <a:p>
-            <a:pPr indent="0" marL="0">
-              <a:buNone/>
-            </a:pPr>
-            <a:r>
-              <a:rPr lang="en-US" sz="1100" b="1" dirty="0">
-                <a:solidFill>
-                  <a:srgbClr val="C9A227"/>
-                </a:solidFill>
-                <a:latin typeface="Microsoft YaHei" pitchFamily="34" charset="0"/>
-                <a:ea typeface="Microsoft YaHei" pitchFamily="34" charset="-122"/>
-                <a:cs typeface="Microsoft YaHei" pitchFamily="34" charset="-120"/>
-              </a:rPr>
-              <a:t>15  </a:t>
-            </a:r>
-            <a:pPr indent="0" marL="0">
-              <a:buNone/>
-            </a:pPr>
-            <a:r>
-              <a:rPr lang="en-US" sz="1450" b="1" dirty="0">
-                <a:solidFill>
-                  <a:srgbClr val="26201C"/>
-                </a:solidFill>
-                <a:latin typeface="Microsoft YaHei" pitchFamily="34" charset="0"/>
-                <a:ea typeface="Microsoft YaHei" pitchFamily="34" charset="-122"/>
-                <a:cs typeface="Microsoft YaHei" pitchFamily="34" charset="-120"/>
-              </a:rPr>
-              <a:t>纪要</a:t>
-            </a:r>
-            <a:endParaRPr lang="en-US" sz="1100" dirty="0"/>
-          </a:p>
-        </p:txBody>
-      </p:sp>
-      <p:sp>
-        <p:nvSpPr>
-          <p:cNvPr id="38" name="Shape 36"/>
           <p:cNvSpPr/>
           <p:nvPr/>
         </p:nvSpPr>
@@ -15198,7 +15136,7 @@
       </p:sp>
       <p:sp>
         <p:nvSpPr>
-          <p:cNvPr id="39" name="Text 37"/>
+          <p:cNvPr id="33" name="Text 31"/>
           <p:cNvSpPr/>
           <p:nvPr/>
         </p:nvSpPr>
@@ -15251,7 +15189,7 @@
       </p:sp>
       <p:sp>
         <p:nvSpPr>
-          <p:cNvPr id="40" name="Shape 38"/>
+          <p:cNvPr id="34" name="Shape 32"/>
           <p:cNvSpPr/>
           <p:nvPr/>
         </p:nvSpPr>
@@ -15273,7 +15211,7 @@
       </p:sp>
       <p:sp>
         <p:nvSpPr>
-          <p:cNvPr id="41" name="Text 39"/>
+          <p:cNvPr id="35" name="Text 33"/>
           <p:cNvSpPr/>
           <p:nvPr/>
         </p:nvSpPr>
@@ -15326,7 +15264,7 @@
       </p:sp>
       <p:sp>
         <p:nvSpPr>
-          <p:cNvPr id="42" name="Text 40"/>
+          <p:cNvPr id="36" name="Text 34"/>
           <p:cNvSpPr/>
           <p:nvPr/>
         </p:nvSpPr>
@@ -16911,7 +16849,7 @@
                 <a:ea typeface="Microsoft YaHei" pitchFamily="34" charset="-122"/>
                 <a:cs typeface="Microsoft YaHei" pitchFamily="34" charset="-120"/>
               </a:rPr>
-              <a:t>15 种文种骨架 · 文秘工具箱 · 写作参考 · 三级纠错</a:t>
+              <a:t>12 种军队文种骨架 · 文秘工具箱 · 写作参考 · 三级纠错</a:t>
             </a:r>
             <a:endParaRPr lang="en-US" sz="1650" dirty="0"/>
           </a:p>
@@ -17365,7 +17303,7 @@
                 <a:ea typeface="Microsoft YaHei" pitchFamily="34" charset="-122"/>
                 <a:cs typeface="Microsoft YaHei" pitchFamily="34" charset="-120"/>
               </a:rPr>
-              <a:t>40 页 · 7 大章节</a:t>
+              <a:t>42 页 · 7 大章节</a:t>
             </a:r>
             <a:endParaRPr lang="en-US" sz="1350" dirty="0"/>
           </a:p>
@@ -23208,7 +23146,7 @@
                 <a:ea typeface="Microsoft YaHei" pitchFamily="34" charset="-122"/>
                 <a:cs typeface="Microsoft YaHei" pitchFamily="34" charset="-120"/>
               </a:rPr>
-              <a:t>默认模板：GB/T 9704-2012 开箱即用</a:t>
+              <a:t>默认模板：军队机关公文格式开箱即用</a:t>
             </a:r>
             <a:endParaRPr lang="en-US" sz="2600" dirty="0"/>
           </a:p>
@@ -23970,7 +23908,7 @@
                 <a:ea typeface="Microsoft YaHei" pitchFamily="34" charset="-122"/>
                 <a:cs typeface="Microsoft YaHei" pitchFamily="34" charset="-120"/>
               </a:rPr>
-              <a:t>封面 · 目录 · 版记 · 水印 / 密级标注（秘密★1年）</a:t>
+              <a:t>封面 · 目录 · 版记 · 水印 / 密级标注（绝密·核心 / 绝密 / 机密 / 秘密）</a:t>
             </a:r>
             <a:endParaRPr lang="en-US" sz="1300" dirty="0"/>
           </a:p>
@@ -28205,7 +28143,7 @@
                 <a:ea typeface="Microsoft YaHei" pitchFamily="34" charset="-122"/>
                 <a:cs typeface="Microsoft YaHei" pitchFamily="34" charset="-120"/>
               </a:rPr>
-              <a:t>GB/T 9704 格式体检：编号链条到字体行距</a:t>
+              <a:t>军队公文格式体检：编号链条到字体行距</a:t>
             </a:r>
             <a:endParaRPr lang="en-US" sz="1350" dirty="0"/>
           </a:p>
@@ -36391,7 +36329,7 @@
                 <a:ea typeface="Microsoft YaHei" pitchFamily="34" charset="-122"/>
                 <a:cs typeface="Microsoft YaHei" pitchFamily="34" charset="-120"/>
               </a:rPr>
-              <a:t>质量保障：1118 项测试，性能指标写进断言</a:t>
+              <a:t>质量保障：1127 项测试，性能指标写进断言</a:t>
             </a:r>
             <a:endParaRPr lang="en-US" sz="2600" dirty="0"/>
           </a:p>
@@ -37429,7 +37367,7 @@
                 <a:ea typeface="Microsoft YaHei" pitchFamily="34" charset="-122"/>
                 <a:cs typeface="Microsoft YaHei" pitchFamily="34" charset="-120"/>
               </a:rPr>
-              <a:t>合计 1118 用例 · 61 个测试文件 · 每次提交 ruff E9+F821 静态门槛（拦截“忘导入即崩溃”）</a:t>
+              <a:t>合计 1127 用例 · 62 个测试文件 · ruff 门槛 E9+F+FA100/FA102+B+PLW2901（拦“忘导入即崩溃”“py39 注解崩”“未用符号回归”）</a:t>
             </a:r>
             <a:endParaRPr lang="en-US" sz="1150" dirty="0"/>
           </a:p>
@@ -37972,7 +37910,7 @@
                 <a:ea typeface="Microsoft YaHei" pitchFamily="34" charset="-122"/>
                 <a:cs typeface="Microsoft YaHei" pitchFamily="34" charset="-120"/>
               </a:rPr>
-              <a:t>18 步全 PASS</a:t>
+              <a:t>20 步全 PASS</a:t>
             </a:r>
             <a:endParaRPr lang="en-US" sz="1500" dirty="0"/>
           </a:p>
@@ -38833,7 +38771,7 @@
                 <a:ea typeface="Microsoft YaHei" pitchFamily="34" charset="-122"/>
                 <a:cs typeface="Microsoft YaHei" pitchFamily="34" charset="-120"/>
               </a:rPr>
-              <a:t>GB/T 9704 默认模板 + 一键汇编，红头目录页码自动生成</a:t>
+              <a:t>军队机关公文格式默认模板 + 一键汇编，红头目录页码自动生成</a:t>
             </a:r>
             <a:endParaRPr lang="en-US" sz="1550" dirty="0"/>
           </a:p>
@@ -39089,7 +39027,7 @@
                 <a:ea typeface="Microsoft YaHei" pitchFamily="34" charset="-122"/>
                 <a:cs typeface="Microsoft YaHei" pitchFamily="34" charset="-120"/>
               </a:rPr>
-              <a:t>15 种法定文种骨架 + 三库联合检索，双击即插入</a:t>
+              <a:t>12 种军队机关公文文种骨架 + 三库联合检索，双击即插入</a:t>
             </a:r>
             <a:endParaRPr lang="en-US" sz="1550" dirty="0"/>
           </a:p>
@@ -40012,6 +39950,2480 @@
     <p:bg>
       <p:bgPr>
         <a:solidFill>
+          <a:srgbClr val="FFFFFF"/>
+        </a:solidFill>
+      </p:bgPr>
+    </p:bg>
+    <p:spTree>
+      <p:nvGrpSpPr>
+        <p:cNvPr id="1" name=""/>
+        <p:cNvGrpSpPr/>
+        <p:nvPr/>
+      </p:nvGrpSpPr>
+      <p:grpSpPr>
+        <a:xfrm>
+          <a:off x="0" y="0"/>
+          <a:ext cx="0" cy="0"/>
+          <a:chOff x="0" y="0"/>
+          <a:chExt cx="0" cy="0"/>
+        </a:xfrm>
+      </p:grpSpPr>
+      <p:sp>
+        <p:nvSpPr>
+          <p:cNvPr id="2" name="Shape 0"/>
+          <p:cNvSpPr/>
+          <p:nvPr/>
+        </p:nvSpPr>
+        <p:spPr>
+          <a:xfrm>
+            <a:off x="457200" y="384048"/>
+            <a:ext cx="347472" cy="347472"/>
+          </a:xfrm>
+          <a:prstGeom prst="roundRect">
+            <a:avLst>
+              <a:gd name="adj" fmla="val 10000"/>
+            </a:avLst>
+          </a:prstGeom>
+          <a:solidFill>
+            <a:srgbClr val="9E2B25"/>
+          </a:solidFill>
+          <a:ln/>
+        </p:spPr>
+      </p:sp>
+      <p:sp>
+        <p:nvSpPr>
+          <p:cNvPr id="3" name="Text 1"/>
+          <p:cNvSpPr/>
+          <p:nvPr/>
+        </p:nvSpPr>
+        <p:spPr>
+          <a:xfrm>
+            <a:off x="457200" y="373624"/>
+            <a:ext cx="347472" cy="347472"/>
+          </a:xfrm>
+          <a:prstGeom prst="rect">
+            <a:avLst/>
+          </a:prstGeom>
+          <a:noFill/>
+          <a:ln/>
+        </p:spPr>
+        <p:txBody>
+          <a:bodyPr wrap="square" lIns="0" tIns="0" rIns="0" bIns="0" rtlCol="0" anchor="ctr"/>
+          <a:lstStyle/>
+          <a:p>
+            <a:pPr algn="ctr" indent="0" marL="0">
+              <a:buNone/>
+            </a:pPr>
+            <a:r>
+              <a:rPr lang="en-US" sz="1400" b="1" dirty="0">
+                <a:solidFill>
+                  <a:srgbClr val="FFFFFF"/>
+                </a:solidFill>
+                <a:latin typeface="Microsoft YaHei" pitchFamily="34" charset="0"/>
+                <a:ea typeface="Microsoft YaHei" pitchFamily="34" charset="-122"/>
+                <a:cs typeface="Microsoft YaHei" pitchFamily="34" charset="-120"/>
+              </a:rPr>
+              <a:t>文</a:t>
+            </a:r>
+            <a:endParaRPr lang="en-US" sz="1400" dirty="0"/>
+          </a:p>
+        </p:txBody>
+      </p:sp>
+      <p:sp>
+        <p:nvSpPr>
+          <p:cNvPr id="4" name="Text 2"/>
+          <p:cNvSpPr/>
+          <p:nvPr/>
+        </p:nvSpPr>
+        <p:spPr>
+          <a:xfrm>
+            <a:off x="914400" y="384048"/>
+            <a:ext cx="7315200" cy="347472"/>
+          </a:xfrm>
+          <a:prstGeom prst="rect">
+            <a:avLst/>
+          </a:prstGeom>
+          <a:noFill/>
+          <a:ln/>
+        </p:spPr>
+        <p:txBody>
+          <a:bodyPr wrap="square" lIns="0" tIns="0" rIns="0" bIns="0" rtlCol="0" anchor="ctr"/>
+          <a:lstStyle/>
+          <a:p>
+            <a:pPr indent="0" marL="0">
+              <a:buNone/>
+            </a:pPr>
+            <a:r>
+              <a:rPr lang="en-US" sz="1200" b="1" spc="200" kern="0" dirty="0">
+                <a:solidFill>
+                  <a:srgbClr val="9E2B25"/>
+                </a:solidFill>
+                <a:latin typeface="Microsoft YaHei" pitchFamily="34" charset="0"/>
+                <a:ea typeface="Microsoft YaHei" pitchFamily="34" charset="-122"/>
+                <a:cs typeface="Microsoft YaHei" pitchFamily="34" charset="-120"/>
+              </a:rPr>
+              <a:t>07 交付、质量与生态</a:t>
+            </a:r>
+            <a:endParaRPr lang="en-US" sz="1200" dirty="0"/>
+          </a:p>
+        </p:txBody>
+      </p:sp>
+      <p:sp>
+        <p:nvSpPr>
+          <p:cNvPr id="5" name="Text 3"/>
+          <p:cNvSpPr/>
+          <p:nvPr/>
+        </p:nvSpPr>
+        <p:spPr>
+          <a:xfrm>
+            <a:off x="457200" y="841248"/>
+            <a:ext cx="11274552" cy="566928"/>
+          </a:xfrm>
+          <a:prstGeom prst="rect">
+            <a:avLst/>
+          </a:prstGeom>
+          <a:noFill/>
+          <a:ln/>
+        </p:spPr>
+        <p:txBody>
+          <a:bodyPr wrap="square" lIns="0" tIns="0" rIns="0" bIns="0" rtlCol="0" anchor="ctr"/>
+          <a:lstStyle/>
+          <a:p>
+            <a:pPr indent="0" marL="0">
+              <a:buNone/>
+            </a:pPr>
+            <a:r>
+              <a:rPr lang="en-US" sz="2600" b="1" dirty="0">
+                <a:solidFill>
+                  <a:srgbClr val="26201C"/>
+                </a:solidFill>
+                <a:latin typeface="Microsoft YaHei" pitchFamily="34" charset="0"/>
+                <a:ea typeface="Microsoft YaHei" pitchFamily="34" charset="-122"/>
+                <a:cs typeface="Microsoft YaHei" pitchFamily="34" charset="-120"/>
+              </a:rPr>
+              <a:t>规范依据与资料来源（逐项可溯）</a:t>
+            </a:r>
+            <a:endParaRPr lang="en-US" sz="2600" dirty="0"/>
+          </a:p>
+        </p:txBody>
+      </p:sp>
+      <p:sp>
+        <p:nvSpPr>
+          <p:cNvPr id="6" name="Text 4"/>
+          <p:cNvSpPr/>
+          <p:nvPr/>
+        </p:nvSpPr>
+        <p:spPr>
+          <a:xfrm>
+            <a:off x="11137392" y="6382512"/>
+            <a:ext cx="594360" cy="292608"/>
+          </a:xfrm>
+          <a:prstGeom prst="rect">
+            <a:avLst/>
+          </a:prstGeom>
+          <a:noFill/>
+          <a:ln/>
+        </p:spPr>
+        <p:txBody>
+          <a:bodyPr wrap="square" lIns="0" tIns="0" rIns="0" bIns="0" rtlCol="0" anchor="ctr"/>
+          <a:lstStyle/>
+          <a:p>
+            <a:pPr algn="r" indent="0" marL="0">
+              <a:buNone/>
+            </a:pPr>
+            <a:r>
+              <a:rPr lang="en-US" sz="1200" dirty="0">
+                <a:solidFill>
+                  <a:srgbClr val="8C8178"/>
+                </a:solidFill>
+                <a:latin typeface="Microsoft YaHei" pitchFamily="34" charset="0"/>
+                <a:ea typeface="Microsoft YaHei" pitchFamily="34" charset="-122"/>
+                <a:cs typeface="Microsoft YaHei" pitchFamily="34" charset="-120"/>
+              </a:rPr>
+              <a:t>41</a:t>
+            </a:r>
+            <a:endParaRPr lang="en-US" sz="1200" dirty="0"/>
+          </a:p>
+        </p:txBody>
+      </p:sp>
+      <p:sp>
+        <p:nvSpPr>
+          <p:cNvPr id="7" name="Text 5"/>
+          <p:cNvSpPr/>
+          <p:nvPr/>
+        </p:nvSpPr>
+        <p:spPr>
+          <a:xfrm>
+            <a:off x="457200" y="6382512"/>
+            <a:ext cx="2926080" cy="292608"/>
+          </a:xfrm>
+          <a:prstGeom prst="rect">
+            <a:avLst/>
+          </a:prstGeom>
+          <a:noFill/>
+          <a:ln/>
+        </p:spPr>
+        <p:txBody>
+          <a:bodyPr wrap="square" lIns="0" tIns="0" rIns="0" bIns="0" rtlCol="0" anchor="ctr"/>
+          <a:lstStyle/>
+          <a:p>
+            <a:pPr indent="0" marL="0">
+              <a:buNone/>
+            </a:pPr>
+            <a:r>
+              <a:rPr lang="en-US" sz="1200" dirty="0">
+                <a:solidFill>
+                  <a:srgbClr val="8C8178"/>
+                </a:solidFill>
+                <a:latin typeface="Microsoft YaHei" pitchFamily="34" charset="0"/>
+                <a:ea typeface="Microsoft YaHei" pitchFamily="34" charset="-122"/>
+                <a:cs typeface="Microsoft YaHei" pitchFamily="34" charset="-120"/>
+              </a:rPr>
+              <a:t>公文汇编助手 · 系统介绍</a:t>
+            </a:r>
+            <a:endParaRPr lang="en-US" sz="1200" dirty="0"/>
+          </a:p>
+        </p:txBody>
+      </p:sp>
+      <p:sp>
+        <p:nvSpPr>
+          <p:cNvPr id="8" name="Shape 6"/>
+          <p:cNvSpPr/>
+          <p:nvPr/>
+        </p:nvSpPr>
+        <p:spPr>
+          <a:xfrm>
+            <a:off x="457200" y="1572768"/>
+            <a:ext cx="11247120" cy="676656"/>
+          </a:xfrm>
+          <a:prstGeom prst="roundRect">
+            <a:avLst>
+              <a:gd name="adj" fmla="val 8108"/>
+            </a:avLst>
+          </a:prstGeom>
+          <a:solidFill>
+            <a:srgbClr val="F5EAE7"/>
+          </a:solidFill>
+          <a:ln w="12700">
+            <a:solidFill>
+              <a:srgbClr val="E7DFD5"/>
+            </a:solidFill>
+            <a:prstDash val="solid"/>
+          </a:ln>
+        </p:spPr>
+      </p:sp>
+      <p:sp>
+        <p:nvSpPr>
+          <p:cNvPr id="9" name="Text 7"/>
+          <p:cNvSpPr/>
+          <p:nvPr/>
+        </p:nvSpPr>
+        <p:spPr>
+          <a:xfrm>
+            <a:off x="566928" y="1618488"/>
+            <a:ext cx="2633472" cy="585216"/>
+          </a:xfrm>
+          <a:prstGeom prst="rect">
+            <a:avLst/>
+          </a:prstGeom>
+          <a:noFill/>
+          <a:ln/>
+        </p:spPr>
+        <p:txBody>
+          <a:bodyPr wrap="square" lIns="0" tIns="0" rIns="0" bIns="0" rtlCol="0" anchor="ctr"/>
+          <a:lstStyle/>
+          <a:p>
+            <a:pPr indent="0" marL="0">
+              <a:lnSpc>
+                <a:spcPct val="112000"/>
+              </a:lnSpc>
+              <a:buNone/>
+            </a:pPr>
+            <a:r>
+              <a:rPr lang="en-US" sz="1150" b="1" dirty="0">
+                <a:solidFill>
+                  <a:srgbClr val="9E2B25"/>
+                </a:solidFill>
+                <a:latin typeface="Microsoft YaHei" pitchFamily="34" charset="0"/>
+                <a:ea typeface="Microsoft YaHei" pitchFamily="34" charset="-122"/>
+                <a:cs typeface="Microsoft YaHei" pitchFamily="34" charset="-120"/>
+              </a:rPr>
+              <a:t>《军队机关公文处理工作条例》</a:t>
+            </a:r>
+            <a:endParaRPr lang="en-US" sz="1150" dirty="0"/>
+          </a:p>
+        </p:txBody>
+      </p:sp>
+      <p:sp>
+        <p:nvSpPr>
+          <p:cNvPr id="10" name="Text 8"/>
+          <p:cNvSpPr/>
+          <p:nvPr/>
+        </p:nvSpPr>
+        <p:spPr>
+          <a:xfrm>
+            <a:off x="3383280" y="1618488"/>
+            <a:ext cx="2907792" cy="585216"/>
+          </a:xfrm>
+          <a:prstGeom prst="rect">
+            <a:avLst/>
+          </a:prstGeom>
+          <a:noFill/>
+          <a:ln/>
+        </p:spPr>
+        <p:txBody>
+          <a:bodyPr wrap="square" lIns="0" tIns="0" rIns="0" bIns="0" rtlCol="0" anchor="ctr"/>
+          <a:lstStyle/>
+          <a:p>
+            <a:pPr indent="0" marL="0">
+              <a:lnSpc>
+                <a:spcPct val="112000"/>
+              </a:lnSpc>
+              <a:buNone/>
+            </a:pPr>
+            <a:r>
+              <a:rPr lang="en-US" sz="1050" dirty="0">
+                <a:solidFill>
+                  <a:srgbClr val="26201C"/>
+                </a:solidFill>
+                <a:latin typeface="Microsoft YaHei" pitchFamily="34" charset="0"/>
+                <a:ea typeface="Microsoft YaHei" pitchFamily="34" charset="-122"/>
+                <a:cs typeface="Microsoft YaHei" pitchFamily="34" charset="-120"/>
+              </a:rPr>
+              <a:t>解放军报 2017-07-17 全文发布</a:t>
+            </a:r>
+            <a:endParaRPr lang="en-US" sz="1050" dirty="0"/>
+          </a:p>
+          <a:p>
+            <a:pPr indent="0" marL="0">
+              <a:lnSpc>
+                <a:spcPct val="112000"/>
+              </a:lnSpc>
+              <a:buNone/>
+            </a:pPr>
+            <a:r>
+              <a:rPr lang="en-US" sz="1050" dirty="0">
+                <a:solidFill>
+                  <a:srgbClr val="26201C"/>
+                </a:solidFill>
+                <a:latin typeface="Microsoft YaHei" pitchFamily="34" charset="0"/>
+                <a:ea typeface="Microsoft YaHei" pitchFamily="34" charset="-122"/>
+                <a:cs typeface="Microsoft YaHei" pitchFamily="34" charset="-120"/>
+              </a:rPr>
+              <a:t>2017-10-01 施行，废止 2005 年版</a:t>
+            </a:r>
+            <a:endParaRPr lang="en-US" sz="1050" dirty="0"/>
+          </a:p>
+        </p:txBody>
+      </p:sp>
+      <p:sp>
+        <p:nvSpPr>
+          <p:cNvPr id="11" name="Text 9"/>
+          <p:cNvSpPr/>
+          <p:nvPr/>
+        </p:nvSpPr>
+        <p:spPr>
+          <a:xfrm>
+            <a:off x="6492240" y="1618488"/>
+            <a:ext cx="5010912" cy="585216"/>
+          </a:xfrm>
+          <a:prstGeom prst="rect">
+            <a:avLst/>
+          </a:prstGeom>
+          <a:noFill/>
+          <a:ln/>
+        </p:spPr>
+        <p:txBody>
+          <a:bodyPr wrap="square" lIns="0" tIns="0" rIns="0" bIns="0" rtlCol="0" anchor="ctr"/>
+          <a:lstStyle/>
+          <a:p>
+            <a:pPr indent="0" marL="0">
+              <a:lnSpc>
+                <a:spcPct val="112000"/>
+              </a:lnSpc>
+              <a:buNone/>
+            </a:pPr>
+            <a:r>
+              <a:rPr lang="en-US" sz="1050" dirty="0">
+                <a:solidFill>
+                  <a:srgbClr val="26201C"/>
+                </a:solidFill>
+                <a:latin typeface="Microsoft YaHei" pitchFamily="34" charset="0"/>
+                <a:ea typeface="Microsoft YaHei" pitchFamily="34" charset="-122"/>
+                <a:cs typeface="Microsoft YaHei" pitchFamily="34" charset="-120"/>
+              </a:rPr>
+              <a:t>文种（12 种）· 格式要素（20 项）· 行文规则 · 起草语言要求（内容简洁、主题突出、观点鲜明、结构严谨、表述准确、文字精练）</a:t>
+            </a:r>
+            <a:endParaRPr lang="en-US" sz="1050" dirty="0"/>
+          </a:p>
+        </p:txBody>
+      </p:sp>
+      <p:sp>
+        <p:nvSpPr>
+          <p:cNvPr id="12" name="Shape 10"/>
+          <p:cNvSpPr/>
+          <p:nvPr/>
+        </p:nvSpPr>
+        <p:spPr>
+          <a:xfrm>
+            <a:off x="457200" y="2322576"/>
+            <a:ext cx="11247120" cy="1024128"/>
+          </a:xfrm>
+          <a:prstGeom prst="roundRect">
+            <a:avLst>
+              <a:gd name="adj" fmla="val 5357"/>
+            </a:avLst>
+          </a:prstGeom>
+          <a:solidFill>
+            <a:srgbClr val="F8F4EE"/>
+          </a:solidFill>
+          <a:ln w="12700">
+            <a:solidFill>
+              <a:srgbClr val="E7DFD5"/>
+            </a:solidFill>
+            <a:prstDash val="solid"/>
+          </a:ln>
+        </p:spPr>
+      </p:sp>
+      <p:sp>
+        <p:nvSpPr>
+          <p:cNvPr id="13" name="Text 11"/>
+          <p:cNvSpPr/>
+          <p:nvPr/>
+        </p:nvSpPr>
+        <p:spPr>
+          <a:xfrm>
+            <a:off x="566928" y="2368296"/>
+            <a:ext cx="2633472" cy="932688"/>
+          </a:xfrm>
+          <a:prstGeom prst="rect">
+            <a:avLst/>
+          </a:prstGeom>
+          <a:noFill/>
+          <a:ln/>
+        </p:spPr>
+        <p:txBody>
+          <a:bodyPr wrap="square" lIns="0" tIns="0" rIns="0" bIns="0" rtlCol="0" anchor="ctr"/>
+          <a:lstStyle/>
+          <a:p>
+            <a:pPr indent="0" marL="0">
+              <a:lnSpc>
+                <a:spcPct val="112000"/>
+              </a:lnSpc>
+              <a:buNone/>
+            </a:pPr>
+            <a:r>
+              <a:rPr lang="en-US" sz="1150" b="1" dirty="0">
+                <a:solidFill>
+                  <a:srgbClr val="9E2B25"/>
+                </a:solidFill>
+                <a:latin typeface="Microsoft YaHei" pitchFamily="34" charset="0"/>
+                <a:ea typeface="Microsoft YaHei" pitchFamily="34" charset="-122"/>
+                <a:cs typeface="Microsoft YaHei" pitchFamily="34" charset="-120"/>
+              </a:rPr>
+              <a:t>GJB 5100A-2017《军队机关公文格式》</a:t>
+            </a:r>
+            <a:endParaRPr lang="en-US" sz="1150" dirty="0"/>
+          </a:p>
+        </p:txBody>
+      </p:sp>
+      <p:sp>
+        <p:nvSpPr>
+          <p:cNvPr id="14" name="Text 12"/>
+          <p:cNvSpPr/>
+          <p:nvPr/>
+        </p:nvSpPr>
+        <p:spPr>
+          <a:xfrm>
+            <a:off x="3383280" y="2368296"/>
+            <a:ext cx="2907792" cy="932688"/>
+          </a:xfrm>
+          <a:prstGeom prst="rect">
+            <a:avLst/>
+          </a:prstGeom>
+          <a:noFill/>
+          <a:ln/>
+        </p:spPr>
+        <p:txBody>
+          <a:bodyPr wrap="square" lIns="0" tIns="0" rIns="0" bIns="0" rtlCol="0" anchor="ctr"/>
+          <a:lstStyle/>
+          <a:p>
+            <a:pPr indent="0" marL="0">
+              <a:lnSpc>
+                <a:spcPct val="112000"/>
+              </a:lnSpc>
+              <a:buNone/>
+            </a:pPr>
+            <a:r>
+              <a:rPr lang="en-US" sz="1050" dirty="0">
+                <a:solidFill>
+                  <a:srgbClr val="26201C"/>
+                </a:solidFill>
+                <a:latin typeface="Microsoft YaHei" pitchFamily="34" charset="0"/>
+                <a:ea typeface="Microsoft YaHei" pitchFamily="34" charset="-122"/>
+                <a:cs typeface="Microsoft YaHei" pitchFamily="34" charset="-120"/>
+              </a:rPr>
+              <a:t>国家军用标准</a:t>
+            </a:r>
+            <a:endParaRPr lang="en-US" sz="1050" dirty="0"/>
+          </a:p>
+          <a:p>
+            <a:pPr indent="0" marL="0">
+              <a:lnSpc>
+                <a:spcPct val="112000"/>
+              </a:lnSpc>
+              <a:buNone/>
+            </a:pPr>
+            <a:r>
+              <a:rPr lang="en-US" sz="1050" dirty="0">
+                <a:solidFill>
+                  <a:srgbClr val="26201C"/>
+                </a:solidFill>
+                <a:latin typeface="Microsoft YaHei" pitchFamily="34" charset="0"/>
+                <a:ea typeface="Microsoft YaHei" pitchFamily="34" charset="-122"/>
+                <a:cs typeface="Microsoft YaHei" pitchFamily="34" charset="-120"/>
+              </a:rPr>
+              <a:t>2017 年发布，36 页</a:t>
+            </a:r>
+            <a:endParaRPr lang="en-US" sz="1050" dirty="0"/>
+          </a:p>
+        </p:txBody>
+      </p:sp>
+      <p:sp>
+        <p:nvSpPr>
+          <p:cNvPr id="15" name="Text 13"/>
+          <p:cNvSpPr/>
+          <p:nvPr/>
+        </p:nvSpPr>
+        <p:spPr>
+          <a:xfrm>
+            <a:off x="6492240" y="2368296"/>
+            <a:ext cx="5010912" cy="932688"/>
+          </a:xfrm>
+          <a:prstGeom prst="rect">
+            <a:avLst/>
+          </a:prstGeom>
+          <a:noFill/>
+          <a:ln/>
+        </p:spPr>
+        <p:txBody>
+          <a:bodyPr wrap="square" lIns="0" tIns="0" rIns="0" bIns="0" rtlCol="0" anchor="ctr"/>
+          <a:lstStyle/>
+          <a:p>
+            <a:pPr indent="0" marL="0">
+              <a:lnSpc>
+                <a:spcPct val="112000"/>
+              </a:lnSpc>
+              <a:buNone/>
+            </a:pPr>
+            <a:r>
+              <a:rPr lang="en-US" sz="1050" dirty="0">
+                <a:solidFill>
+                  <a:srgbClr val="26201C"/>
+                </a:solidFill>
+                <a:latin typeface="Microsoft YaHei" pitchFamily="34" charset="0"/>
+                <a:ea typeface="Microsoft YaHei" pitchFamily="34" charset="-122"/>
+                <a:cs typeface="Microsoft YaHei" pitchFamily="34" charset="-120"/>
+              </a:rPr>
+              <a:t>页面与字体字号：A4 · 天头 37mm · 订口 28mm · 版心 156mm×225mm · 每面 22 行×28 字；正文三号仿宋 · 标题二号小标宋 · 密级三号黑体 · 页码四号半角白体</a:t>
+            </a:r>
+            <a:endParaRPr lang="en-US" sz="1050" dirty="0"/>
+          </a:p>
+        </p:txBody>
+      </p:sp>
+      <p:sp>
+        <p:nvSpPr>
+          <p:cNvPr id="16" name="Shape 14"/>
+          <p:cNvSpPr/>
+          <p:nvPr/>
+        </p:nvSpPr>
+        <p:spPr>
+          <a:xfrm>
+            <a:off x="457200" y="3419856"/>
+            <a:ext cx="11247120" cy="676656"/>
+          </a:xfrm>
+          <a:prstGeom prst="roundRect">
+            <a:avLst>
+              <a:gd name="adj" fmla="val 8108"/>
+            </a:avLst>
+          </a:prstGeom>
+          <a:solidFill>
+            <a:srgbClr val="F5EAE7"/>
+          </a:solidFill>
+          <a:ln w="12700">
+            <a:solidFill>
+              <a:srgbClr val="E7DFD5"/>
+            </a:solidFill>
+            <a:prstDash val="solid"/>
+          </a:ln>
+        </p:spPr>
+      </p:sp>
+      <p:sp>
+        <p:nvSpPr>
+          <p:cNvPr id="17" name="Text 15"/>
+          <p:cNvSpPr/>
+          <p:nvPr/>
+        </p:nvSpPr>
+        <p:spPr>
+          <a:xfrm>
+            <a:off x="566928" y="3465576"/>
+            <a:ext cx="2633472" cy="585216"/>
+          </a:xfrm>
+          <a:prstGeom prst="rect">
+            <a:avLst/>
+          </a:prstGeom>
+          <a:noFill/>
+          <a:ln/>
+        </p:spPr>
+        <p:txBody>
+          <a:bodyPr wrap="square" lIns="0" tIns="0" rIns="0" bIns="0" rtlCol="0" anchor="ctr"/>
+          <a:lstStyle/>
+          <a:p>
+            <a:pPr indent="0" marL="0">
+              <a:lnSpc>
+                <a:spcPct val="112000"/>
+              </a:lnSpc>
+              <a:buNone/>
+            </a:pPr>
+            <a:r>
+              <a:rPr lang="en-US" sz="1150" b="1" dirty="0">
+                <a:solidFill>
+                  <a:srgbClr val="9E2B25"/>
+                </a:solidFill>
+                <a:latin typeface="Microsoft YaHei" pitchFamily="34" charset="0"/>
+                <a:ea typeface="Microsoft YaHei" pitchFamily="34" charset="-122"/>
+                <a:cs typeface="Microsoft YaHei" pitchFamily="34" charset="-120"/>
+              </a:rPr>
+              <a:t>求是网 · 文风建设系列文章</a:t>
+            </a:r>
+            <a:endParaRPr lang="en-US" sz="1150" dirty="0"/>
+          </a:p>
+        </p:txBody>
+      </p:sp>
+      <p:sp>
+        <p:nvSpPr>
+          <p:cNvPr id="18" name="Text 16"/>
+          <p:cNvSpPr/>
+          <p:nvPr/>
+        </p:nvSpPr>
+        <p:spPr>
+          <a:xfrm>
+            <a:off x="3383280" y="3465576"/>
+            <a:ext cx="2907792" cy="585216"/>
+          </a:xfrm>
+          <a:prstGeom prst="rect">
+            <a:avLst/>
+          </a:prstGeom>
+          <a:noFill/>
+          <a:ln/>
+        </p:spPr>
+        <p:txBody>
+          <a:bodyPr wrap="square" lIns="0" tIns="0" rIns="0" bIns="0" rtlCol="0" anchor="ctr"/>
+          <a:lstStyle/>
+          <a:p>
+            <a:pPr indent="0" marL="0">
+              <a:lnSpc>
+                <a:spcPct val="112000"/>
+              </a:lnSpc>
+              <a:buNone/>
+            </a:pPr>
+            <a:r>
+              <a:rPr lang="en-US" sz="1050" dirty="0">
+                <a:solidFill>
+                  <a:srgbClr val="26201C"/>
+                </a:solidFill>
+                <a:latin typeface="Microsoft YaHei" pitchFamily="34" charset="0"/>
+                <a:ea typeface="Microsoft YaHei" pitchFamily="34" charset="-122"/>
+                <a:cs typeface="Microsoft YaHei" pitchFamily="34" charset="-120"/>
+              </a:rPr>
+              <a:t>《“改文风”不只是“改文字”》等 3 篇</a:t>
+            </a:r>
+            <a:endParaRPr lang="en-US" sz="1050" dirty="0"/>
+          </a:p>
+        </p:txBody>
+      </p:sp>
+      <p:sp>
+        <p:nvSpPr>
+          <p:cNvPr id="19" name="Text 17"/>
+          <p:cNvSpPr/>
+          <p:nvPr/>
+        </p:nvSpPr>
+        <p:spPr>
+          <a:xfrm>
+            <a:off x="6492240" y="3465576"/>
+            <a:ext cx="5010912" cy="585216"/>
+          </a:xfrm>
+          <a:prstGeom prst="rect">
+            <a:avLst/>
+          </a:prstGeom>
+          <a:noFill/>
+          <a:ln/>
+        </p:spPr>
+        <p:txBody>
+          <a:bodyPr wrap="square" lIns="0" tIns="0" rIns="0" bIns="0" rtlCol="0" anchor="ctr"/>
+          <a:lstStyle/>
+          <a:p>
+            <a:pPr indent="0" marL="0">
+              <a:lnSpc>
+                <a:spcPct val="112000"/>
+              </a:lnSpc>
+              <a:buNone/>
+            </a:pPr>
+            <a:r>
+              <a:rPr lang="en-US" sz="1050" dirty="0">
+                <a:solidFill>
+                  <a:srgbClr val="26201C"/>
+                </a:solidFill>
+                <a:latin typeface="Microsoft YaHei" pitchFamily="34" charset="0"/>
+                <a:ea typeface="Microsoft YaHei" pitchFamily="34" charset="-122"/>
+                <a:cs typeface="Microsoft YaHei" pitchFamily="34" charset="-120"/>
+              </a:rPr>
+              <a:t>文风检查依据：反对“长、空、假”，倡导“短、实、新”</a:t>
+            </a:r>
+            <a:endParaRPr lang="en-US" sz="1050" dirty="0"/>
+          </a:p>
+        </p:txBody>
+      </p:sp>
+      <p:sp>
+        <p:nvSpPr>
+          <p:cNvPr id="20" name="Shape 18"/>
+          <p:cNvSpPr/>
+          <p:nvPr/>
+        </p:nvSpPr>
+        <p:spPr>
+          <a:xfrm>
+            <a:off x="457200" y="4169664"/>
+            <a:ext cx="11247120" cy="676656"/>
+          </a:xfrm>
+          <a:prstGeom prst="roundRect">
+            <a:avLst>
+              <a:gd name="adj" fmla="val 8108"/>
+            </a:avLst>
+          </a:prstGeom>
+          <a:solidFill>
+            <a:srgbClr val="F8F4EE"/>
+          </a:solidFill>
+          <a:ln w="12700">
+            <a:solidFill>
+              <a:srgbClr val="E7DFD5"/>
+            </a:solidFill>
+            <a:prstDash val="solid"/>
+          </a:ln>
+        </p:spPr>
+      </p:sp>
+      <p:sp>
+        <p:nvSpPr>
+          <p:cNvPr id="21" name="Text 19"/>
+          <p:cNvSpPr/>
+          <p:nvPr/>
+        </p:nvSpPr>
+        <p:spPr>
+          <a:xfrm>
+            <a:off x="566928" y="4215384"/>
+            <a:ext cx="2633472" cy="585216"/>
+          </a:xfrm>
+          <a:prstGeom prst="rect">
+            <a:avLst/>
+          </a:prstGeom>
+          <a:noFill/>
+          <a:ln/>
+        </p:spPr>
+        <p:txBody>
+          <a:bodyPr wrap="square" lIns="0" tIns="0" rIns="0" bIns="0" rtlCol="0" anchor="ctr"/>
+          <a:lstStyle/>
+          <a:p>
+            <a:pPr indent="0" marL="0">
+              <a:lnSpc>
+                <a:spcPct val="112000"/>
+              </a:lnSpc>
+              <a:buNone/>
+            </a:pPr>
+            <a:r>
+              <a:rPr lang="en-US" sz="1150" b="1" dirty="0">
+                <a:solidFill>
+                  <a:srgbClr val="9E2B25"/>
+                </a:solidFill>
+                <a:latin typeface="Microsoft YaHei" pitchFamily="34" charset="0"/>
+                <a:ea typeface="Microsoft YaHei" pitchFamily="34" charset="-122"/>
+                <a:cs typeface="Microsoft YaHei" pitchFamily="34" charset="-120"/>
+              </a:rPr>
+              <a:t>中国军网 · 解放军报</a:t>
+            </a:r>
+            <a:endParaRPr lang="en-US" sz="1150" dirty="0"/>
+          </a:p>
+        </p:txBody>
+      </p:sp>
+      <p:sp>
+        <p:nvSpPr>
+          <p:cNvPr id="22" name="Text 20"/>
+          <p:cNvSpPr/>
+          <p:nvPr/>
+        </p:nvSpPr>
+        <p:spPr>
+          <a:xfrm>
+            <a:off x="3383280" y="4215384"/>
+            <a:ext cx="2907792" cy="585216"/>
+          </a:xfrm>
+          <a:prstGeom prst="rect">
+            <a:avLst/>
+          </a:prstGeom>
+          <a:noFill/>
+          <a:ln/>
+        </p:spPr>
+        <p:txBody>
+          <a:bodyPr wrap="square" lIns="0" tIns="0" rIns="0" bIns="0" rtlCol="0" anchor="ctr"/>
+          <a:lstStyle/>
+          <a:p>
+            <a:pPr indent="0" marL="0">
+              <a:lnSpc>
+                <a:spcPct val="112000"/>
+              </a:lnSpc>
+              <a:buNone/>
+            </a:pPr>
+            <a:r>
+              <a:rPr lang="en-US" sz="1050" dirty="0">
+                <a:solidFill>
+                  <a:srgbClr val="26201C"/>
+                </a:solidFill>
+                <a:latin typeface="Microsoft YaHei" pitchFamily="34" charset="0"/>
+                <a:ea typeface="Microsoft YaHei" pitchFamily="34" charset="-122"/>
+                <a:cs typeface="Microsoft YaHei" pitchFamily="34" charset="-120"/>
+              </a:rPr>
+              <a:t>中国人民解放军官方军事新闻门户</a:t>
+            </a:r>
+            <a:endParaRPr lang="en-US" sz="1050" dirty="0"/>
+          </a:p>
+        </p:txBody>
+      </p:sp>
+      <p:sp>
+        <p:nvSpPr>
+          <p:cNvPr id="23" name="Text 21"/>
+          <p:cNvSpPr/>
+          <p:nvPr/>
+        </p:nvSpPr>
+        <p:spPr>
+          <a:xfrm>
+            <a:off x="6492240" y="4215384"/>
+            <a:ext cx="5010912" cy="585216"/>
+          </a:xfrm>
+          <a:prstGeom prst="rect">
+            <a:avLst/>
+          </a:prstGeom>
+          <a:noFill/>
+          <a:ln/>
+        </p:spPr>
+        <p:txBody>
+          <a:bodyPr wrap="square" lIns="0" tIns="0" rIns="0" bIns="0" rtlCol="0" anchor="ctr"/>
+          <a:lstStyle/>
+          <a:p>
+            <a:pPr indent="0" marL="0">
+              <a:lnSpc>
+                <a:spcPct val="112000"/>
+              </a:lnSpc>
+              <a:buNone/>
+            </a:pPr>
+            <a:r>
+              <a:rPr lang="en-US" sz="1050" dirty="0">
+                <a:solidFill>
+                  <a:srgbClr val="26201C"/>
+                </a:solidFill>
+                <a:latin typeface="Microsoft YaHei" pitchFamily="34" charset="0"/>
+                <a:ea typeface="Microsoft YaHei" pitchFamily="34" charset="-122"/>
+                <a:cs typeface="Microsoft YaHei" pitchFamily="34" charset="-120"/>
+              </a:rPr>
+              <a:t>军队机关公文规范的发布渠道与权威来源</a:t>
+            </a:r>
+            <a:endParaRPr lang="en-US" sz="1050" dirty="0"/>
+          </a:p>
+        </p:txBody>
+      </p:sp>
+      <p:sp>
+        <p:nvSpPr>
+          <p:cNvPr id="24" name="Shape 22"/>
+          <p:cNvSpPr/>
+          <p:nvPr/>
+        </p:nvSpPr>
+        <p:spPr>
+          <a:xfrm>
+            <a:off x="457200" y="4919472"/>
+            <a:ext cx="11247120" cy="896112"/>
+          </a:xfrm>
+          <a:prstGeom prst="roundRect">
+            <a:avLst>
+              <a:gd name="adj" fmla="val 6122"/>
+            </a:avLst>
+          </a:prstGeom>
+          <a:solidFill>
+            <a:srgbClr val="F5EAE7"/>
+          </a:solidFill>
+          <a:ln w="12700">
+            <a:solidFill>
+              <a:srgbClr val="E7DFD5"/>
+            </a:solidFill>
+            <a:prstDash val="solid"/>
+          </a:ln>
+        </p:spPr>
+      </p:sp>
+      <p:sp>
+        <p:nvSpPr>
+          <p:cNvPr id="25" name="Text 23"/>
+          <p:cNvSpPr/>
+          <p:nvPr/>
+        </p:nvSpPr>
+        <p:spPr>
+          <a:xfrm>
+            <a:off x="566928" y="4965192"/>
+            <a:ext cx="2633472" cy="804672"/>
+          </a:xfrm>
+          <a:prstGeom prst="rect">
+            <a:avLst/>
+          </a:prstGeom>
+          <a:noFill/>
+          <a:ln/>
+        </p:spPr>
+        <p:txBody>
+          <a:bodyPr wrap="square" lIns="0" tIns="0" rIns="0" bIns="0" rtlCol="0" anchor="ctr"/>
+          <a:lstStyle/>
+          <a:p>
+            <a:pPr indent="0" marL="0">
+              <a:lnSpc>
+                <a:spcPct val="112000"/>
+              </a:lnSpc>
+              <a:buNone/>
+            </a:pPr>
+            <a:r>
+              <a:rPr lang="en-US" sz="1150" b="1" dirty="0">
+                <a:solidFill>
+                  <a:srgbClr val="9E2B25"/>
+                </a:solidFill>
+                <a:latin typeface="Microsoft YaHei" pitchFamily="34" charset="0"/>
+                <a:ea typeface="Microsoft YaHei" pitchFamily="34" charset="-122"/>
+                <a:cs typeface="Microsoft YaHei" pitchFamily="34" charset="-120"/>
+              </a:rPr>
+              <a:t>文籍典册 wendian.dicomp.net</a:t>
+            </a:r>
+            <a:endParaRPr lang="en-US" sz="1150" dirty="0"/>
+          </a:p>
+        </p:txBody>
+      </p:sp>
+      <p:sp>
+        <p:nvSpPr>
+          <p:cNvPr id="26" name="Text 24"/>
+          <p:cNvSpPr/>
+          <p:nvPr/>
+        </p:nvSpPr>
+        <p:spPr>
+          <a:xfrm>
+            <a:off x="3383280" y="4965192"/>
+            <a:ext cx="2907792" cy="804672"/>
+          </a:xfrm>
+          <a:prstGeom prst="rect">
+            <a:avLst/>
+          </a:prstGeom>
+          <a:noFill/>
+          <a:ln/>
+        </p:spPr>
+        <p:txBody>
+          <a:bodyPr wrap="square" lIns="0" tIns="0" rIns="0" bIns="0" rtlCol="0" anchor="ctr"/>
+          <a:lstStyle/>
+          <a:p>
+            <a:pPr indent="0" marL="0">
+              <a:lnSpc>
+                <a:spcPct val="112000"/>
+              </a:lnSpc>
+              <a:buNone/>
+            </a:pPr>
+            <a:r>
+              <a:rPr lang="en-US" sz="1050" dirty="0">
+                <a:solidFill>
+                  <a:srgbClr val="26201C"/>
+                </a:solidFill>
+                <a:latin typeface="Microsoft YaHei" pitchFamily="34" charset="0"/>
+                <a:ea typeface="Microsoft YaHei" pitchFamily="34" charset="-122"/>
+                <a:cs typeface="Microsoft YaHei" pitchFamily="34" charset="-120"/>
+              </a:rPr>
+              <a:t>外部站点</a:t>
+            </a:r>
+            <a:endParaRPr lang="en-US" sz="1050" dirty="0"/>
+          </a:p>
+        </p:txBody>
+      </p:sp>
+      <p:sp>
+        <p:nvSpPr>
+          <p:cNvPr id="27" name="Text 25"/>
+          <p:cNvSpPr/>
+          <p:nvPr/>
+        </p:nvSpPr>
+        <p:spPr>
+          <a:xfrm>
+            <a:off x="6492240" y="4965192"/>
+            <a:ext cx="5010912" cy="804672"/>
+          </a:xfrm>
+          <a:prstGeom prst="rect">
+            <a:avLst/>
+          </a:prstGeom>
+          <a:noFill/>
+          <a:ln/>
+        </p:spPr>
+        <p:txBody>
+          <a:bodyPr wrap="square" lIns="0" tIns="0" rIns="0" bIns="0" rtlCol="0" anchor="ctr"/>
+          <a:lstStyle/>
+          <a:p>
+            <a:pPr indent="0" marL="0">
+              <a:lnSpc>
+                <a:spcPct val="112000"/>
+              </a:lnSpc>
+              <a:buNone/>
+            </a:pPr>
+            <a:r>
+              <a:rPr lang="en-US" sz="1050" dirty="0">
+                <a:solidFill>
+                  <a:srgbClr val="26201C"/>
+                </a:solidFill>
+                <a:latin typeface="Microsoft YaHei" pitchFamily="34" charset="0"/>
+                <a:ea typeface="Microsoft YaHei" pitchFamily="34" charset="-122"/>
+                <a:cs typeface="Microsoft YaHei" pitchFamily="34" charset="-120"/>
+              </a:rPr>
+              <a:t>核验为 JavaScript 单页应用，未取到与本文档主张对应的正文 —— 按约定标注“不适用”，不作引用</a:t>
+            </a:r>
+            <a:endParaRPr lang="en-US" sz="1050" dirty="0"/>
+          </a:p>
+        </p:txBody>
+      </p:sp>
+      <p:sp>
+        <p:nvSpPr>
+          <p:cNvPr id="28" name="Text 26"/>
+          <p:cNvSpPr/>
+          <p:nvPr/>
+        </p:nvSpPr>
+        <p:spPr>
+          <a:xfrm>
+            <a:off x="457200" y="5870448"/>
+            <a:ext cx="11247120" cy="457200"/>
+          </a:xfrm>
+          <a:prstGeom prst="rect">
+            <a:avLst/>
+          </a:prstGeom>
+          <a:noFill/>
+          <a:ln/>
+        </p:spPr>
+        <p:txBody>
+          <a:bodyPr wrap="square" lIns="0" tIns="0" rIns="0" bIns="0" rtlCol="0" anchor="ctr"/>
+          <a:lstStyle/>
+          <a:p>
+            <a:pPr indent="0" marL="0">
+              <a:lnSpc>
+                <a:spcPct val="115000"/>
+              </a:lnSpc>
+              <a:buNone/>
+            </a:pPr>
+            <a:r>
+              <a:rPr lang="en-US" sz="1000" b="1" dirty="0">
+                <a:solidFill>
+                  <a:srgbClr val="9E2B25"/>
+                </a:solidFill>
+                <a:latin typeface="Microsoft YaHei" pitchFamily="34" charset="0"/>
+                <a:ea typeface="Microsoft YaHei" pitchFamily="34" charset="-122"/>
+                <a:cs typeface="Microsoft YaHei" pitchFamily="34" charset="-120"/>
+              </a:rPr>
+              <a:t>字体字号说明：</a:t>
+            </a:r>
+            <a:pPr indent="0" marL="0">
+              <a:lnSpc>
+                <a:spcPct val="115000"/>
+              </a:lnSpc>
+              <a:buNone/>
+            </a:pPr>
+            <a:r>
+              <a:rPr lang="en-US" sz="1000" dirty="0">
+                <a:solidFill>
+                  <a:srgbClr val="8C8178"/>
+                </a:solidFill>
+                <a:latin typeface="Microsoft YaHei" pitchFamily="34" charset="0"/>
+                <a:ea typeface="Microsoft YaHei" pitchFamily="34" charset="-122"/>
+                <a:cs typeface="Microsoft YaHei" pitchFamily="34" charset="-120"/>
+              </a:rPr>
+              <a:t>GJB 5100A-2017 属内部标准、未公开发行，上表字体字号取自公开整理的对应条款；如与标准正式文本有出入，以正式文本为准。文籍典册经核验无对应正文，故不引用。</a:t>
+            </a:r>
+            <a:endParaRPr lang="en-US" sz="1000" dirty="0"/>
+          </a:p>
+        </p:txBody>
+      </p:sp>
+    </p:spTree>
+  </p:cSld>
+  <p:clrMapOvr>
+    <a:masterClrMapping/>
+  </p:clrMapOvr>
+</p:sld>
+</file>
+
+<file path=ppt/slides/slide42.xml><?xml version="1.0" encoding="utf-8"?>
+<p:sld xmlns:a="http://schemas.openxmlformats.org/drawingml/2006/main" xmlns:r="http://schemas.openxmlformats.org/officeDocument/2006/relationships" xmlns:p="http://schemas.openxmlformats.org/presentationml/2006/main">
+  <p:cSld name="Slide 42">
+    <p:bg>
+      <p:bgPr>
+        <a:solidFill>
+          <a:srgbClr val="FFFFFF"/>
+        </a:solidFill>
+      </p:bgPr>
+    </p:bg>
+    <p:spTree>
+      <p:nvGrpSpPr>
+        <p:cNvPr id="1" name=""/>
+        <p:cNvGrpSpPr/>
+        <p:nvPr/>
+      </p:nvGrpSpPr>
+      <p:grpSpPr>
+        <a:xfrm>
+          <a:off x="0" y="0"/>
+          <a:ext cx="0" cy="0"/>
+          <a:chOff x="0" y="0"/>
+          <a:chExt cx="0" cy="0"/>
+        </a:xfrm>
+      </p:grpSpPr>
+      <p:sp>
+        <p:nvSpPr>
+          <p:cNvPr id="2" name="Shape 0"/>
+          <p:cNvSpPr/>
+          <p:nvPr/>
+        </p:nvSpPr>
+        <p:spPr>
+          <a:xfrm>
+            <a:off x="457200" y="384048"/>
+            <a:ext cx="347472" cy="347472"/>
+          </a:xfrm>
+          <a:prstGeom prst="roundRect">
+            <a:avLst>
+              <a:gd name="adj" fmla="val 10000"/>
+            </a:avLst>
+          </a:prstGeom>
+          <a:solidFill>
+            <a:srgbClr val="9E2B25"/>
+          </a:solidFill>
+          <a:ln/>
+        </p:spPr>
+      </p:sp>
+      <p:sp>
+        <p:nvSpPr>
+          <p:cNvPr id="3" name="Text 1"/>
+          <p:cNvSpPr/>
+          <p:nvPr/>
+        </p:nvSpPr>
+        <p:spPr>
+          <a:xfrm>
+            <a:off x="457200" y="373624"/>
+            <a:ext cx="347472" cy="347472"/>
+          </a:xfrm>
+          <a:prstGeom prst="rect">
+            <a:avLst/>
+          </a:prstGeom>
+          <a:noFill/>
+          <a:ln/>
+        </p:spPr>
+        <p:txBody>
+          <a:bodyPr wrap="square" lIns="0" tIns="0" rIns="0" bIns="0" rtlCol="0" anchor="ctr"/>
+          <a:lstStyle/>
+          <a:p>
+            <a:pPr algn="ctr" indent="0" marL="0">
+              <a:buNone/>
+            </a:pPr>
+            <a:r>
+              <a:rPr lang="en-US" sz="1400" b="1" dirty="0">
+                <a:solidFill>
+                  <a:srgbClr val="FFFFFF"/>
+                </a:solidFill>
+                <a:latin typeface="Microsoft YaHei" pitchFamily="34" charset="0"/>
+                <a:ea typeface="Microsoft YaHei" pitchFamily="34" charset="-122"/>
+                <a:cs typeface="Microsoft YaHei" pitchFamily="34" charset="-120"/>
+              </a:rPr>
+              <a:t>文</a:t>
+            </a:r>
+            <a:endParaRPr lang="en-US" sz="1400" dirty="0"/>
+          </a:p>
+        </p:txBody>
+      </p:sp>
+      <p:sp>
+        <p:nvSpPr>
+          <p:cNvPr id="4" name="Text 2"/>
+          <p:cNvSpPr/>
+          <p:nvPr/>
+        </p:nvSpPr>
+        <p:spPr>
+          <a:xfrm>
+            <a:off x="914400" y="384048"/>
+            <a:ext cx="7315200" cy="347472"/>
+          </a:xfrm>
+          <a:prstGeom prst="rect">
+            <a:avLst/>
+          </a:prstGeom>
+          <a:noFill/>
+          <a:ln/>
+        </p:spPr>
+        <p:txBody>
+          <a:bodyPr wrap="square" lIns="0" tIns="0" rIns="0" bIns="0" rtlCol="0" anchor="ctr"/>
+          <a:lstStyle/>
+          <a:p>
+            <a:pPr indent="0" marL="0">
+              <a:buNone/>
+            </a:pPr>
+            <a:r>
+              <a:rPr lang="en-US" sz="1200" b="1" spc="200" kern="0" dirty="0">
+                <a:solidFill>
+                  <a:srgbClr val="9E2B25"/>
+                </a:solidFill>
+                <a:latin typeface="Microsoft YaHei" pitchFamily="34" charset="0"/>
+                <a:ea typeface="Microsoft YaHei" pitchFamily="34" charset="-122"/>
+                <a:cs typeface="Microsoft YaHei" pitchFamily="34" charset="-120"/>
+              </a:rPr>
+              <a:t>07 交付、质量与生态</a:t>
+            </a:r>
+            <a:endParaRPr lang="en-US" sz="1200" dirty="0"/>
+          </a:p>
+        </p:txBody>
+      </p:sp>
+      <p:sp>
+        <p:nvSpPr>
+          <p:cNvPr id="5" name="Text 3"/>
+          <p:cNvSpPr/>
+          <p:nvPr/>
+        </p:nvSpPr>
+        <p:spPr>
+          <a:xfrm>
+            <a:off x="457200" y="841248"/>
+            <a:ext cx="11274552" cy="566928"/>
+          </a:xfrm>
+          <a:prstGeom prst="rect">
+            <a:avLst/>
+          </a:prstGeom>
+          <a:noFill/>
+          <a:ln/>
+        </p:spPr>
+        <p:txBody>
+          <a:bodyPr wrap="square" lIns="0" tIns="0" rIns="0" bIns="0" rtlCol="0" anchor="ctr"/>
+          <a:lstStyle/>
+          <a:p>
+            <a:pPr indent="0" marL="0">
+              <a:buNone/>
+            </a:pPr>
+            <a:r>
+              <a:rPr lang="en-US" sz="2600" b="1" dirty="0">
+                <a:solidFill>
+                  <a:srgbClr val="26201C"/>
+                </a:solidFill>
+                <a:latin typeface="Microsoft YaHei" pitchFamily="34" charset="0"/>
+                <a:ea typeface="Microsoft YaHei" pitchFamily="34" charset="-122"/>
+                <a:cs typeface="Microsoft YaHei" pitchFamily="34" charset="-120"/>
+              </a:rPr>
+              <a:t>代码审查：请一把外部尺子，把 39,358 行逐一过筛</a:t>
+            </a:r>
+            <a:endParaRPr lang="en-US" sz="2600" dirty="0"/>
+          </a:p>
+        </p:txBody>
+      </p:sp>
+      <p:sp>
+        <p:nvSpPr>
+          <p:cNvPr id="6" name="Text 4"/>
+          <p:cNvSpPr/>
+          <p:nvPr/>
+        </p:nvSpPr>
+        <p:spPr>
+          <a:xfrm>
+            <a:off x="11137392" y="6382512"/>
+            <a:ext cx="594360" cy="292608"/>
+          </a:xfrm>
+          <a:prstGeom prst="rect">
+            <a:avLst/>
+          </a:prstGeom>
+          <a:noFill/>
+          <a:ln/>
+        </p:spPr>
+        <p:txBody>
+          <a:bodyPr wrap="square" lIns="0" tIns="0" rIns="0" bIns="0" rtlCol="0" anchor="ctr"/>
+          <a:lstStyle/>
+          <a:p>
+            <a:pPr algn="r" indent="0" marL="0">
+              <a:buNone/>
+            </a:pPr>
+            <a:r>
+              <a:rPr lang="en-US" sz="1200" dirty="0">
+                <a:solidFill>
+                  <a:srgbClr val="8C8178"/>
+                </a:solidFill>
+                <a:latin typeface="Microsoft YaHei" pitchFamily="34" charset="0"/>
+                <a:ea typeface="Microsoft YaHei" pitchFamily="34" charset="-122"/>
+                <a:cs typeface="Microsoft YaHei" pitchFamily="34" charset="-120"/>
+              </a:rPr>
+              <a:t>42</a:t>
+            </a:r>
+            <a:endParaRPr lang="en-US" sz="1200" dirty="0"/>
+          </a:p>
+        </p:txBody>
+      </p:sp>
+      <p:sp>
+        <p:nvSpPr>
+          <p:cNvPr id="7" name="Text 5"/>
+          <p:cNvSpPr/>
+          <p:nvPr/>
+        </p:nvSpPr>
+        <p:spPr>
+          <a:xfrm>
+            <a:off x="457200" y="6382512"/>
+            <a:ext cx="2926080" cy="292608"/>
+          </a:xfrm>
+          <a:prstGeom prst="rect">
+            <a:avLst/>
+          </a:prstGeom>
+          <a:noFill/>
+          <a:ln/>
+        </p:spPr>
+        <p:txBody>
+          <a:bodyPr wrap="square" lIns="0" tIns="0" rIns="0" bIns="0" rtlCol="0" anchor="ctr"/>
+          <a:lstStyle/>
+          <a:p>
+            <a:pPr indent="0" marL="0">
+              <a:buNone/>
+            </a:pPr>
+            <a:r>
+              <a:rPr lang="en-US" sz="1200" dirty="0">
+                <a:solidFill>
+                  <a:srgbClr val="8C8178"/>
+                </a:solidFill>
+                <a:latin typeface="Microsoft YaHei" pitchFamily="34" charset="0"/>
+                <a:ea typeface="Microsoft YaHei" pitchFamily="34" charset="-122"/>
+                <a:cs typeface="Microsoft YaHei" pitchFamily="34" charset="-120"/>
+              </a:rPr>
+              <a:t>公文汇编助手 · 系统介绍</a:t>
+            </a:r>
+            <a:endParaRPr lang="en-US" sz="1200" dirty="0"/>
+          </a:p>
+        </p:txBody>
+      </p:sp>
+      <p:sp>
+        <p:nvSpPr>
+          <p:cNvPr id="8" name="Shape 6"/>
+          <p:cNvSpPr/>
+          <p:nvPr/>
+        </p:nvSpPr>
+        <p:spPr>
+          <a:xfrm>
+            <a:off x="457200" y="1600200"/>
+            <a:ext cx="5394960" cy="4480560"/>
+          </a:xfrm>
+          <a:prstGeom prst="roundRect">
+            <a:avLst>
+              <a:gd name="adj" fmla="val 1633"/>
+            </a:avLst>
+          </a:prstGeom>
+          <a:solidFill>
+            <a:srgbClr val="F8F4EE"/>
+          </a:solidFill>
+          <a:ln w="12700">
+            <a:solidFill>
+              <a:srgbClr val="E7DFD5"/>
+            </a:solidFill>
+            <a:prstDash val="solid"/>
+          </a:ln>
+        </p:spPr>
+      </p:sp>
+      <p:sp>
+        <p:nvSpPr>
+          <p:cNvPr id="9" name="Text 7"/>
+          <p:cNvSpPr/>
+          <p:nvPr/>
+        </p:nvSpPr>
+        <p:spPr>
+          <a:xfrm>
+            <a:off x="713232" y="1783080"/>
+            <a:ext cx="4846320" cy="365760"/>
+          </a:xfrm>
+          <a:prstGeom prst="rect">
+            <a:avLst/>
+          </a:prstGeom>
+          <a:noFill/>
+          <a:ln/>
+        </p:spPr>
+        <p:txBody>
+          <a:bodyPr wrap="square" lIns="0" tIns="0" rIns="0" bIns="0" rtlCol="0" anchor="ctr"/>
+          <a:lstStyle/>
+          <a:p>
+            <a:pPr indent="0" marL="0">
+              <a:buNone/>
+            </a:pPr>
+            <a:r>
+              <a:rPr lang="en-US" sz="1500" b="1" dirty="0">
+                <a:solidFill>
+                  <a:srgbClr val="9E2B25"/>
+                </a:solidFill>
+                <a:latin typeface="Microsoft YaHei" pitchFamily="34" charset="0"/>
+                <a:ea typeface="Microsoft YaHei" pitchFamily="34" charset="-122"/>
+                <a:cs typeface="Microsoft YaHei" pitchFamily="34" charset="-120"/>
+              </a:rPr>
+              <a:t>怎么审的</a:t>
+            </a:r>
+            <a:endParaRPr lang="en-US" sz="1500" dirty="0"/>
+          </a:p>
+        </p:txBody>
+      </p:sp>
+      <p:sp>
+        <p:nvSpPr>
+          <p:cNvPr id="10" name="Shape 8"/>
+          <p:cNvSpPr/>
+          <p:nvPr/>
+        </p:nvSpPr>
+        <p:spPr>
+          <a:xfrm>
+            <a:off x="713232" y="2322576"/>
+            <a:ext cx="100584" cy="100584"/>
+          </a:xfrm>
+          <a:prstGeom prst="rect">
+            <a:avLst/>
+          </a:prstGeom>
+          <a:solidFill>
+            <a:srgbClr val="9E2B25"/>
+          </a:solidFill>
+          <a:ln/>
+        </p:spPr>
+      </p:sp>
+      <p:sp>
+        <p:nvSpPr>
+          <p:cNvPr id="11" name="Text 9"/>
+          <p:cNvSpPr/>
+          <p:nvPr/>
+        </p:nvSpPr>
+        <p:spPr>
+          <a:xfrm>
+            <a:off x="950976" y="2240280"/>
+            <a:ext cx="4700016" cy="731520"/>
+          </a:xfrm>
+          <a:prstGeom prst="rect">
+            <a:avLst/>
+          </a:prstGeom>
+          <a:noFill/>
+          <a:ln/>
+        </p:spPr>
+        <p:txBody>
+          <a:bodyPr wrap="square" lIns="0" tIns="0" rIns="0" bIns="0" rtlCol="0" anchor="t"/>
+          <a:lstStyle/>
+          <a:p>
+            <a:pPr indent="0" marL="0">
+              <a:lnSpc>
+                <a:spcPct val="112000"/>
+              </a:lnSpc>
+              <a:buNone/>
+            </a:pPr>
+            <a:r>
+              <a:rPr lang="en-US" sz="1300" b="1" dirty="0">
+                <a:solidFill>
+                  <a:srgbClr val="26201C"/>
+                </a:solidFill>
+                <a:latin typeface="Microsoft YaHei" pitchFamily="34" charset="0"/>
+                <a:ea typeface="Microsoft YaHei" pitchFamily="34" charset="-122"/>
+                <a:cs typeface="Microsoft YaHei" pitchFamily="34" charset="-120"/>
+              </a:rPr>
+              <a:t>工具</a:t>
+            </a:r>
+            <a:pPr indent="0" marL="0">
+              <a:lnSpc>
+                <a:spcPct val="112000"/>
+              </a:lnSpc>
+              <a:buNone/>
+            </a:pPr>
+            <a:r>
+              <a:rPr lang="en-US" sz="1150" dirty="0">
+                <a:solidFill>
+                  <a:srgbClr val="8C8178"/>
+                </a:solidFill>
+                <a:latin typeface="Microsoft YaHei" pitchFamily="34" charset="0"/>
+                <a:ea typeface="Microsoft YaHei" pitchFamily="34" charset="-122"/>
+                <a:cs typeface="Microsoft YaHei" pitchFamily="34" charset="-120"/>
+              </a:rPr>
+              <a:t>　alibaba/open-code-review（混合架构：确定性流水线 + LLM）</a:t>
+            </a:r>
+            <a:endParaRPr lang="en-US" sz="1300" dirty="0"/>
+          </a:p>
+        </p:txBody>
+      </p:sp>
+      <p:sp>
+        <p:nvSpPr>
+          <p:cNvPr id="12" name="Shape 10"/>
+          <p:cNvSpPr/>
+          <p:nvPr/>
+        </p:nvSpPr>
+        <p:spPr>
+          <a:xfrm>
+            <a:off x="713232" y="3163824"/>
+            <a:ext cx="100584" cy="100584"/>
+          </a:xfrm>
+          <a:prstGeom prst="rect">
+            <a:avLst/>
+          </a:prstGeom>
+          <a:solidFill>
+            <a:srgbClr val="9E2B25"/>
+          </a:solidFill>
+          <a:ln/>
+        </p:spPr>
+      </p:sp>
+      <p:sp>
+        <p:nvSpPr>
+          <p:cNvPr id="13" name="Text 11"/>
+          <p:cNvSpPr/>
+          <p:nvPr/>
+        </p:nvSpPr>
+        <p:spPr>
+          <a:xfrm>
+            <a:off x="950976" y="3081528"/>
+            <a:ext cx="4700016" cy="731520"/>
+          </a:xfrm>
+          <a:prstGeom prst="rect">
+            <a:avLst/>
+          </a:prstGeom>
+          <a:noFill/>
+          <a:ln/>
+        </p:spPr>
+        <p:txBody>
+          <a:bodyPr wrap="square" lIns="0" tIns="0" rIns="0" bIns="0" rtlCol="0" anchor="t"/>
+          <a:lstStyle/>
+          <a:p>
+            <a:pPr indent="0" marL="0">
+              <a:lnSpc>
+                <a:spcPct val="112000"/>
+              </a:lnSpc>
+              <a:buNone/>
+            </a:pPr>
+            <a:r>
+              <a:rPr lang="en-US" sz="1300" b="1" dirty="0">
+                <a:solidFill>
+                  <a:srgbClr val="26201C"/>
+                </a:solidFill>
+                <a:latin typeface="Microsoft YaHei" pitchFamily="34" charset="0"/>
+                <a:ea typeface="Microsoft YaHei" pitchFamily="34" charset="-122"/>
+                <a:cs typeface="Microsoft YaHei" pitchFamily="34" charset="-120"/>
+              </a:rPr>
+              <a:t>范围</a:t>
+            </a:r>
+            <a:pPr indent="0" marL="0">
+              <a:lnSpc>
+                <a:spcPct val="112000"/>
+              </a:lnSpc>
+              <a:buNone/>
+            </a:pPr>
+            <a:r>
+              <a:rPr lang="en-US" sz="1150" dirty="0">
+                <a:solidFill>
+                  <a:srgbClr val="8C8178"/>
+                </a:solidFill>
+                <a:latin typeface="Microsoft YaHei" pitchFamily="34" charset="0"/>
+                <a:ea typeface="Microsoft YaHei" pitchFamily="34" charset="-122"/>
+                <a:cs typeface="Microsoft YaHei" pitchFamily="34" charset="-120"/>
+              </a:rPr>
+              <a:t>　161 个文件 / 39,358 行（产品码 76 个模块优先）</a:t>
+            </a:r>
+            <a:endParaRPr lang="en-US" sz="1300" dirty="0"/>
+          </a:p>
+        </p:txBody>
+      </p:sp>
+      <p:sp>
+        <p:nvSpPr>
+          <p:cNvPr id="14" name="Shape 12"/>
+          <p:cNvSpPr/>
+          <p:nvPr/>
+        </p:nvSpPr>
+        <p:spPr>
+          <a:xfrm>
+            <a:off x="713232" y="4005072"/>
+            <a:ext cx="100584" cy="100584"/>
+          </a:xfrm>
+          <a:prstGeom prst="rect">
+            <a:avLst/>
+          </a:prstGeom>
+          <a:solidFill>
+            <a:srgbClr val="9E2B25"/>
+          </a:solidFill>
+          <a:ln/>
+        </p:spPr>
+      </p:sp>
+      <p:sp>
+        <p:nvSpPr>
+          <p:cNvPr id="15" name="Text 13"/>
+          <p:cNvSpPr/>
+          <p:nvPr/>
+        </p:nvSpPr>
+        <p:spPr>
+          <a:xfrm>
+            <a:off x="950976" y="3922776"/>
+            <a:ext cx="4700016" cy="731520"/>
+          </a:xfrm>
+          <a:prstGeom prst="rect">
+            <a:avLst/>
+          </a:prstGeom>
+          <a:noFill/>
+          <a:ln/>
+        </p:spPr>
+        <p:txBody>
+          <a:bodyPr wrap="square" lIns="0" tIns="0" rIns="0" bIns="0" rtlCol="0" anchor="t"/>
+          <a:lstStyle/>
+          <a:p>
+            <a:pPr indent="0" marL="0">
+              <a:lnSpc>
+                <a:spcPct val="112000"/>
+              </a:lnSpc>
+              <a:buNone/>
+            </a:pPr>
+            <a:r>
+              <a:rPr lang="en-US" sz="1300" b="1" dirty="0">
+                <a:solidFill>
+                  <a:srgbClr val="26201C"/>
+                </a:solidFill>
+                <a:latin typeface="Microsoft YaHei" pitchFamily="34" charset="0"/>
+                <a:ea typeface="Microsoft YaHei" pitchFamily="34" charset="-122"/>
+                <a:cs typeface="Microsoft YaHei" pitchFamily="34" charset="-120"/>
+              </a:rPr>
+              <a:t>规则</a:t>
+            </a:r>
+            <a:pPr indent="0" marL="0">
+              <a:lnSpc>
+                <a:spcPct val="112000"/>
+              </a:lnSpc>
+              <a:buNone/>
+            </a:pPr>
+            <a:r>
+              <a:rPr lang="en-US" sz="1150" dirty="0">
+                <a:solidFill>
+                  <a:srgbClr val="8C8178"/>
+                </a:solidFill>
+                <a:latin typeface="Microsoft YaHei" pitchFamily="34" charset="0"/>
+                <a:ea typeface="Microsoft YaHei" pitchFamily="34" charset="-122"/>
+                <a:cs typeface="Microsoft YaHei" pitchFamily="34" charset="-120"/>
+              </a:rPr>
+              <a:t>　内置 11 大类：异常处理 / 边界情形 / 资源管理 / 并发 / 安全…</a:t>
+            </a:r>
+            <a:endParaRPr lang="en-US" sz="1300" dirty="0"/>
+          </a:p>
+        </p:txBody>
+      </p:sp>
+      <p:sp>
+        <p:nvSpPr>
+          <p:cNvPr id="16" name="Shape 14"/>
+          <p:cNvSpPr/>
+          <p:nvPr/>
+        </p:nvSpPr>
+        <p:spPr>
+          <a:xfrm>
+            <a:off x="713232" y="4846320"/>
+            <a:ext cx="100584" cy="100584"/>
+          </a:xfrm>
+          <a:prstGeom prst="rect">
+            <a:avLst/>
+          </a:prstGeom>
+          <a:solidFill>
+            <a:srgbClr val="9E2B25"/>
+          </a:solidFill>
+          <a:ln/>
+        </p:spPr>
+      </p:sp>
+      <p:sp>
+        <p:nvSpPr>
+          <p:cNvPr id="17" name="Text 15"/>
+          <p:cNvSpPr/>
+          <p:nvPr/>
+        </p:nvSpPr>
+        <p:spPr>
+          <a:xfrm>
+            <a:off x="950976" y="4764024"/>
+            <a:ext cx="4700016" cy="731520"/>
+          </a:xfrm>
+          <a:prstGeom prst="rect">
+            <a:avLst/>
+          </a:prstGeom>
+          <a:noFill/>
+          <a:ln/>
+        </p:spPr>
+        <p:txBody>
+          <a:bodyPr wrap="square" lIns="0" tIns="0" rIns="0" bIns="0" rtlCol="0" anchor="t"/>
+          <a:lstStyle/>
+          <a:p>
+            <a:pPr indent="0" marL="0">
+              <a:lnSpc>
+                <a:spcPct val="112000"/>
+              </a:lnSpc>
+              <a:buNone/>
+            </a:pPr>
+            <a:r>
+              <a:rPr lang="en-US" sz="1300" b="1" dirty="0">
+                <a:solidFill>
+                  <a:srgbClr val="26201C"/>
+                </a:solidFill>
+                <a:latin typeface="Microsoft YaHei" pitchFamily="34" charset="0"/>
+                <a:ea typeface="Microsoft YaHei" pitchFamily="34" charset="-122"/>
+                <a:cs typeface="Microsoft YaHei" pitchFamily="34" charset="-120"/>
+              </a:rPr>
+              <a:t>方法</a:t>
+            </a:r>
+            <a:pPr indent="0" marL="0">
+              <a:lnSpc>
+                <a:spcPct val="112000"/>
+              </a:lnSpc>
+              <a:buNone/>
+            </a:pPr>
+            <a:r>
+              <a:rPr lang="en-US" sz="1150" dirty="0">
+                <a:solidFill>
+                  <a:srgbClr val="8C8178"/>
+                </a:solidFill>
+                <a:latin typeface="Microsoft YaHei" pitchFamily="34" charset="0"/>
+                <a:ea typeface="Microsoft YaHei" pitchFamily="34" charset="-122"/>
+                <a:cs typeface="Microsoft YaHei" pitchFamily="34" charset="-120"/>
+              </a:rPr>
+              <a:t>　先机检全量候选，再逐条读上下文判真伪</a:t>
+            </a:r>
+            <a:endParaRPr lang="en-US" sz="1300" dirty="0"/>
+          </a:p>
+        </p:txBody>
+      </p:sp>
+      <p:sp>
+        <p:nvSpPr>
+          <p:cNvPr id="18" name="Text 16"/>
+          <p:cNvSpPr/>
+          <p:nvPr/>
+        </p:nvSpPr>
+        <p:spPr>
+          <a:xfrm>
+            <a:off x="713232" y="5532120"/>
+            <a:ext cx="4937760" cy="457200"/>
+          </a:xfrm>
+          <a:prstGeom prst="rect">
+            <a:avLst/>
+          </a:prstGeom>
+          <a:noFill/>
+          <a:ln/>
+        </p:spPr>
+        <p:txBody>
+          <a:bodyPr wrap="square" lIns="0" tIns="0" rIns="0" bIns="0" rtlCol="0" anchor="ctr"/>
+          <a:lstStyle/>
+          <a:p>
+            <a:pPr indent="0" marL="0">
+              <a:lnSpc>
+                <a:spcPct val="115000"/>
+              </a:lnSpc>
+              <a:buNone/>
+            </a:pPr>
+            <a:r>
+              <a:rPr lang="en-US" sz="1000" b="1" dirty="0">
+                <a:solidFill>
+                  <a:srgbClr val="9E2B25"/>
+                </a:solidFill>
+                <a:latin typeface="Microsoft YaHei" pitchFamily="34" charset="0"/>
+                <a:ea typeface="Microsoft YaHei" pitchFamily="34" charset="-122"/>
+                <a:cs typeface="Microsoft YaHei" pitchFamily="34" charset="-120"/>
+              </a:rPr>
+              <a:t>诚实说明：</a:t>
+            </a:r>
+            <a:pPr indent="0" marL="0">
+              <a:lnSpc>
+                <a:spcPct val="115000"/>
+              </a:lnSpc>
+              <a:buNone/>
+            </a:pPr>
+            <a:r>
+              <a:rPr lang="en-US" sz="1000" dirty="0">
+                <a:solidFill>
+                  <a:srgbClr val="8C8178"/>
+                </a:solidFill>
+                <a:latin typeface="Microsoft YaHei" pitchFamily="34" charset="0"/>
+                <a:ea typeface="Microsoft YaHei" pitchFamily="34" charset="-122"/>
+                <a:cs typeface="Microsoft YaHei" pitchFamily="34" charset="-120"/>
+              </a:rPr>
+              <a:t>工具内置 LLM（deepseek）密钥余额为 0，故改用其官方 delegate 模式 —— 由工具出规则集，由本机 AI 完成推理。</a:t>
+            </a:r>
+            <a:endParaRPr lang="en-US" sz="1000" dirty="0"/>
+          </a:p>
+        </p:txBody>
+      </p:sp>
+      <p:sp>
+        <p:nvSpPr>
+          <p:cNvPr id="19" name="Shape 17"/>
+          <p:cNvSpPr/>
+          <p:nvPr/>
+        </p:nvSpPr>
+        <p:spPr>
+          <a:xfrm>
+            <a:off x="6172200" y="1600200"/>
+            <a:ext cx="5559552" cy="4480560"/>
+          </a:xfrm>
+          <a:prstGeom prst="roundRect">
+            <a:avLst>
+              <a:gd name="adj" fmla="val 1633"/>
+            </a:avLst>
+          </a:prstGeom>
+          <a:solidFill>
+            <a:srgbClr val="1F1917"/>
+          </a:solidFill>
+          <a:ln/>
+        </p:spPr>
+      </p:sp>
+      <p:sp>
+        <p:nvSpPr>
+          <p:cNvPr id="20" name="Text 18"/>
+          <p:cNvSpPr/>
+          <p:nvPr/>
+        </p:nvSpPr>
+        <p:spPr>
+          <a:xfrm>
+            <a:off x="6428232" y="1783080"/>
+            <a:ext cx="5029200" cy="365760"/>
+          </a:xfrm>
+          <a:prstGeom prst="rect">
+            <a:avLst/>
+          </a:prstGeom>
+          <a:noFill/>
+          <a:ln/>
+        </p:spPr>
+        <p:txBody>
+          <a:bodyPr wrap="square" lIns="0" tIns="0" rIns="0" bIns="0" rtlCol="0" anchor="ctr"/>
+          <a:lstStyle/>
+          <a:p>
+            <a:pPr indent="0" marL="0">
+              <a:buNone/>
+            </a:pPr>
+            <a:r>
+              <a:rPr lang="en-US" sz="1500" b="1" dirty="0">
+                <a:solidFill>
+                  <a:srgbClr val="F2D8A0"/>
+                </a:solidFill>
+                <a:latin typeface="Microsoft YaHei" pitchFamily="34" charset="0"/>
+                <a:ea typeface="Microsoft YaHei" pitchFamily="34" charset="-122"/>
+                <a:cs typeface="Microsoft YaHei" pitchFamily="34" charset="-120"/>
+              </a:rPr>
+              <a:t>审出了什么</a:t>
+            </a:r>
+            <a:endParaRPr lang="en-US" sz="1500" dirty="0"/>
+          </a:p>
+        </p:txBody>
+      </p:sp>
+      <p:sp>
+        <p:nvSpPr>
+          <p:cNvPr id="21" name="Text 19"/>
+          <p:cNvSpPr/>
+          <p:nvPr/>
+        </p:nvSpPr>
+        <p:spPr>
+          <a:xfrm>
+            <a:off x="6428232" y="2267712"/>
+            <a:ext cx="2834640" cy="365760"/>
+          </a:xfrm>
+          <a:prstGeom prst="rect">
+            <a:avLst/>
+          </a:prstGeom>
+          <a:noFill/>
+          <a:ln/>
+        </p:spPr>
+        <p:txBody>
+          <a:bodyPr wrap="square" lIns="0" tIns="0" rIns="0" bIns="0" rtlCol="0" anchor="ctr"/>
+          <a:lstStyle/>
+          <a:p>
+            <a:pPr indent="0" marL="0">
+              <a:buNone/>
+            </a:pPr>
+            <a:r>
+              <a:rPr lang="en-US" sz="1250" dirty="0">
+                <a:solidFill>
+                  <a:srgbClr val="EFE7DE"/>
+                </a:solidFill>
+                <a:latin typeface="Microsoft YaHei" pitchFamily="34" charset="0"/>
+                <a:ea typeface="Microsoft YaHei" pitchFamily="34" charset="-122"/>
+                <a:cs typeface="Microsoft YaHei" pitchFamily="34" charset="-120"/>
+              </a:rPr>
+              <a:t>原始候选</a:t>
+            </a:r>
+            <a:endParaRPr lang="en-US" sz="1250" dirty="0"/>
+          </a:p>
+        </p:txBody>
+      </p:sp>
+      <p:sp>
+        <p:nvSpPr>
+          <p:cNvPr id="22" name="Text 20"/>
+          <p:cNvSpPr/>
+          <p:nvPr/>
+        </p:nvSpPr>
+        <p:spPr>
+          <a:xfrm>
+            <a:off x="9235440" y="2267712"/>
+            <a:ext cx="914400" cy="365760"/>
+          </a:xfrm>
+          <a:prstGeom prst="rect">
+            <a:avLst/>
+          </a:prstGeom>
+          <a:noFill/>
+          <a:ln/>
+        </p:spPr>
+        <p:txBody>
+          <a:bodyPr wrap="square" lIns="0" tIns="0" rIns="0" bIns="0" rtlCol="0" anchor="ctr"/>
+          <a:lstStyle/>
+          <a:p>
+            <a:pPr algn="r" indent="0" marL="0">
+              <a:buNone/>
+            </a:pPr>
+            <a:r>
+              <a:rPr lang="en-US" sz="1500" b="1" dirty="0">
+                <a:solidFill>
+                  <a:srgbClr val="A99C90"/>
+                </a:solidFill>
+                <a:latin typeface="Microsoft YaHei" pitchFamily="34" charset="0"/>
+                <a:ea typeface="Microsoft YaHei" pitchFamily="34" charset="-122"/>
+                <a:cs typeface="Microsoft YaHei" pitchFamily="34" charset="-120"/>
+              </a:rPr>
+              <a:t>2368</a:t>
+            </a:r>
+            <a:endParaRPr lang="en-US" sz="1500" dirty="0"/>
+          </a:p>
+        </p:txBody>
+      </p:sp>
+      <p:sp>
+        <p:nvSpPr>
+          <p:cNvPr id="23" name="Text 21"/>
+          <p:cNvSpPr/>
+          <p:nvPr/>
+        </p:nvSpPr>
+        <p:spPr>
+          <a:xfrm>
+            <a:off x="6428232" y="2743200"/>
+            <a:ext cx="2834640" cy="365760"/>
+          </a:xfrm>
+          <a:prstGeom prst="rect">
+            <a:avLst/>
+          </a:prstGeom>
+          <a:noFill/>
+          <a:ln/>
+        </p:spPr>
+        <p:txBody>
+          <a:bodyPr wrap="square" lIns="0" tIns="0" rIns="0" bIns="0" rtlCol="0" anchor="ctr"/>
+          <a:lstStyle/>
+          <a:p>
+            <a:pPr indent="0" marL="0">
+              <a:buNone/>
+            </a:pPr>
+            <a:r>
+              <a:rPr lang="en-US" sz="1250" dirty="0">
+                <a:solidFill>
+                  <a:srgbClr val="EFE7DE"/>
+                </a:solidFill>
+                <a:latin typeface="Microsoft YaHei" pitchFamily="34" charset="0"/>
+                <a:ea typeface="Microsoft YaHei" pitchFamily="34" charset="-122"/>
+                <a:cs typeface="Microsoft YaHei" pitchFamily="34" charset="-120"/>
+              </a:rPr>
+              <a:t>生产代码候选</a:t>
+            </a:r>
+            <a:endParaRPr lang="en-US" sz="1250" dirty="0"/>
+          </a:p>
+        </p:txBody>
+      </p:sp>
+      <p:sp>
+        <p:nvSpPr>
+          <p:cNvPr id="24" name="Text 22"/>
+          <p:cNvSpPr/>
+          <p:nvPr/>
+        </p:nvSpPr>
+        <p:spPr>
+          <a:xfrm>
+            <a:off x="9235440" y="2743200"/>
+            <a:ext cx="914400" cy="365760"/>
+          </a:xfrm>
+          <a:prstGeom prst="rect">
+            <a:avLst/>
+          </a:prstGeom>
+          <a:noFill/>
+          <a:ln/>
+        </p:spPr>
+        <p:txBody>
+          <a:bodyPr wrap="square" lIns="0" tIns="0" rIns="0" bIns="0" rtlCol="0" anchor="ctr"/>
+          <a:lstStyle/>
+          <a:p>
+            <a:pPr algn="r" indent="0" marL="0">
+              <a:buNone/>
+            </a:pPr>
+            <a:r>
+              <a:rPr lang="en-US" sz="1500" b="1" dirty="0">
+                <a:solidFill>
+                  <a:srgbClr val="EFE7DE"/>
+                </a:solidFill>
+                <a:latin typeface="Microsoft YaHei" pitchFamily="34" charset="0"/>
+                <a:ea typeface="Microsoft YaHei" pitchFamily="34" charset="-122"/>
+                <a:cs typeface="Microsoft YaHei" pitchFamily="34" charset="-120"/>
+              </a:rPr>
+              <a:t>82</a:t>
+            </a:r>
+            <a:endParaRPr lang="en-US" sz="1500" dirty="0"/>
+          </a:p>
+        </p:txBody>
+      </p:sp>
+      <p:sp>
+        <p:nvSpPr>
+          <p:cNvPr id="25" name="Text 23"/>
+          <p:cNvSpPr/>
+          <p:nvPr/>
+        </p:nvSpPr>
+        <p:spPr>
+          <a:xfrm>
+            <a:off x="6428232" y="3218688"/>
+            <a:ext cx="2834640" cy="365760"/>
+          </a:xfrm>
+          <a:prstGeom prst="rect">
+            <a:avLst/>
+          </a:prstGeom>
+          <a:noFill/>
+          <a:ln/>
+        </p:spPr>
+        <p:txBody>
+          <a:bodyPr wrap="square" lIns="0" tIns="0" rIns="0" bIns="0" rtlCol="0" anchor="ctr"/>
+          <a:lstStyle/>
+          <a:p>
+            <a:pPr indent="0" marL="0">
+              <a:buNone/>
+            </a:pPr>
+            <a:r>
+              <a:rPr lang="en-US" sz="1250" dirty="0">
+                <a:solidFill>
+                  <a:srgbClr val="EFE7DE"/>
+                </a:solidFill>
+                <a:latin typeface="Microsoft YaHei" pitchFamily="34" charset="0"/>
+                <a:ea typeface="Microsoft YaHei" pitchFamily="34" charset="-122"/>
+                <a:cs typeface="Microsoft YaHei" pitchFamily="34" charset="-120"/>
+              </a:rPr>
+              <a:t>确认缺陷 · 已修</a:t>
+            </a:r>
+            <a:endParaRPr lang="en-US" sz="1250" dirty="0"/>
+          </a:p>
+        </p:txBody>
+      </p:sp>
+      <p:sp>
+        <p:nvSpPr>
+          <p:cNvPr id="26" name="Text 24"/>
+          <p:cNvSpPr/>
+          <p:nvPr/>
+        </p:nvSpPr>
+        <p:spPr>
+          <a:xfrm>
+            <a:off x="9235440" y="3218688"/>
+            <a:ext cx="914400" cy="365760"/>
+          </a:xfrm>
+          <a:prstGeom prst="rect">
+            <a:avLst/>
+          </a:prstGeom>
+          <a:noFill/>
+          <a:ln/>
+        </p:spPr>
+        <p:txBody>
+          <a:bodyPr wrap="square" lIns="0" tIns="0" rIns="0" bIns="0" rtlCol="0" anchor="ctr"/>
+          <a:lstStyle/>
+          <a:p>
+            <a:pPr algn="r" indent="0" marL="0">
+              <a:buNone/>
+            </a:pPr>
+            <a:r>
+              <a:rPr lang="en-US" sz="1900" b="1" dirty="0">
+                <a:solidFill>
+                  <a:srgbClr val="C9A227"/>
+                </a:solidFill>
+                <a:latin typeface="Microsoft YaHei" pitchFamily="34" charset="0"/>
+                <a:ea typeface="Microsoft YaHei" pitchFamily="34" charset="-122"/>
+                <a:cs typeface="Microsoft YaHei" pitchFamily="34" charset="-120"/>
+              </a:rPr>
+              <a:t>12</a:t>
+            </a:r>
+            <a:endParaRPr lang="en-US" sz="1900" dirty="0"/>
+          </a:p>
+        </p:txBody>
+      </p:sp>
+      <p:sp>
+        <p:nvSpPr>
+          <p:cNvPr id="27" name="Text 25"/>
+          <p:cNvSpPr/>
+          <p:nvPr/>
+        </p:nvSpPr>
+        <p:spPr>
+          <a:xfrm>
+            <a:off x="6428232" y="3694176"/>
+            <a:ext cx="2834640" cy="365760"/>
+          </a:xfrm>
+          <a:prstGeom prst="rect">
+            <a:avLst/>
+          </a:prstGeom>
+          <a:noFill/>
+          <a:ln/>
+        </p:spPr>
+        <p:txBody>
+          <a:bodyPr wrap="square" lIns="0" tIns="0" rIns="0" bIns="0" rtlCol="0" anchor="ctr"/>
+          <a:lstStyle/>
+          <a:p>
+            <a:pPr indent="0" marL="0">
+              <a:buNone/>
+            </a:pPr>
+            <a:r>
+              <a:rPr lang="en-US" sz="1250" dirty="0">
+                <a:solidFill>
+                  <a:srgbClr val="EFE7DE"/>
+                </a:solidFill>
+                <a:latin typeface="Microsoft YaHei" pitchFamily="34" charset="0"/>
+                <a:ea typeface="Microsoft YaHei" pitchFamily="34" charset="-122"/>
+                <a:cs typeface="Microsoft YaHei" pitchFamily="34" charset="-120"/>
+              </a:rPr>
+              <a:t>合理降级 · 不动</a:t>
+            </a:r>
+            <a:endParaRPr lang="en-US" sz="1250" dirty="0"/>
+          </a:p>
+        </p:txBody>
+      </p:sp>
+      <p:sp>
+        <p:nvSpPr>
+          <p:cNvPr id="28" name="Text 26"/>
+          <p:cNvSpPr/>
+          <p:nvPr/>
+        </p:nvSpPr>
+        <p:spPr>
+          <a:xfrm>
+            <a:off x="9235440" y="3694176"/>
+            <a:ext cx="914400" cy="365760"/>
+          </a:xfrm>
+          <a:prstGeom prst="rect">
+            <a:avLst/>
+          </a:prstGeom>
+          <a:noFill/>
+          <a:ln/>
+        </p:spPr>
+        <p:txBody>
+          <a:bodyPr wrap="square" lIns="0" tIns="0" rIns="0" bIns="0" rtlCol="0" anchor="ctr"/>
+          <a:lstStyle/>
+          <a:p>
+            <a:pPr algn="r" indent="0" marL="0">
+              <a:buNone/>
+            </a:pPr>
+            <a:r>
+              <a:rPr lang="en-US" sz="1500" b="1" dirty="0">
+                <a:solidFill>
+                  <a:srgbClr val="EFE7DE"/>
+                </a:solidFill>
+                <a:latin typeface="Microsoft YaHei" pitchFamily="34" charset="0"/>
+                <a:ea typeface="Microsoft YaHei" pitchFamily="34" charset="-122"/>
+                <a:cs typeface="Microsoft YaHei" pitchFamily="34" charset="-120"/>
+              </a:rPr>
+              <a:t>62</a:t>
+            </a:r>
+            <a:endParaRPr lang="en-US" sz="1500" dirty="0"/>
+          </a:p>
+        </p:txBody>
+      </p:sp>
+      <p:sp>
+        <p:nvSpPr>
+          <p:cNvPr id="29" name="Text 27"/>
+          <p:cNvSpPr/>
+          <p:nvPr/>
+        </p:nvSpPr>
+        <p:spPr>
+          <a:xfrm>
+            <a:off x="6428232" y="4169664"/>
+            <a:ext cx="2834640" cy="365760"/>
+          </a:xfrm>
+          <a:prstGeom prst="rect">
+            <a:avLst/>
+          </a:prstGeom>
+          <a:noFill/>
+          <a:ln/>
+        </p:spPr>
+        <p:txBody>
+          <a:bodyPr wrap="square" lIns="0" tIns="0" rIns="0" bIns="0" rtlCol="0" anchor="ctr"/>
+          <a:lstStyle/>
+          <a:p>
+            <a:pPr indent="0" marL="0">
+              <a:buNone/>
+            </a:pPr>
+            <a:r>
+              <a:rPr lang="en-US" sz="1250" dirty="0">
+                <a:solidFill>
+                  <a:srgbClr val="EFE7DE"/>
+                </a:solidFill>
+                <a:latin typeface="Microsoft YaHei" pitchFamily="34" charset="0"/>
+                <a:ea typeface="Microsoft YaHei" pitchFamily="34" charset="-122"/>
+                <a:cs typeface="Microsoft YaHei" pitchFamily="34" charset="-120"/>
+              </a:rPr>
+              <a:t>误报 · 剔除</a:t>
+            </a:r>
+            <a:endParaRPr lang="en-US" sz="1250" dirty="0"/>
+          </a:p>
+        </p:txBody>
+      </p:sp>
+      <p:sp>
+        <p:nvSpPr>
+          <p:cNvPr id="30" name="Text 28"/>
+          <p:cNvSpPr/>
+          <p:nvPr/>
+        </p:nvSpPr>
+        <p:spPr>
+          <a:xfrm>
+            <a:off x="9235440" y="4169664"/>
+            <a:ext cx="914400" cy="365760"/>
+          </a:xfrm>
+          <a:prstGeom prst="rect">
+            <a:avLst/>
+          </a:prstGeom>
+          <a:noFill/>
+          <a:ln/>
+        </p:spPr>
+        <p:txBody>
+          <a:bodyPr wrap="square" lIns="0" tIns="0" rIns="0" bIns="0" rtlCol="0" anchor="ctr"/>
+          <a:lstStyle/>
+          <a:p>
+            <a:pPr algn="r" indent="0" marL="0">
+              <a:buNone/>
+            </a:pPr>
+            <a:r>
+              <a:rPr lang="en-US" sz="1500" b="1" dirty="0">
+                <a:solidFill>
+                  <a:srgbClr val="A99C90"/>
+                </a:solidFill>
+                <a:latin typeface="Microsoft YaHei" pitchFamily="34" charset="0"/>
+                <a:ea typeface="Microsoft YaHei" pitchFamily="34" charset="-122"/>
+                <a:cs typeface="Microsoft YaHei" pitchFamily="34" charset="-120"/>
+              </a:rPr>
+              <a:t>8</a:t>
+            </a:r>
+            <a:endParaRPr lang="en-US" sz="1500" dirty="0"/>
+          </a:p>
+        </p:txBody>
+      </p:sp>
+      <p:sp>
+        <p:nvSpPr>
+          <p:cNvPr id="31" name="Shape 29"/>
+          <p:cNvSpPr/>
+          <p:nvPr/>
+        </p:nvSpPr>
+        <p:spPr>
+          <a:xfrm>
+            <a:off x="6428232" y="4709160"/>
+            <a:ext cx="5029200" cy="0"/>
+          </a:xfrm>
+          <a:prstGeom prst="line">
+            <a:avLst/>
+          </a:prstGeom>
+          <a:noFill/>
+          <a:ln w="12700">
+            <a:solidFill>
+              <a:srgbClr val="4A3F38"/>
+            </a:solidFill>
+            <a:prstDash val="solid"/>
+          </a:ln>
+        </p:spPr>
+      </p:sp>
+      <p:sp>
+        <p:nvSpPr>
+          <p:cNvPr id="32" name="Text 30"/>
+          <p:cNvSpPr/>
+          <p:nvPr/>
+        </p:nvSpPr>
+        <p:spPr>
+          <a:xfrm>
+            <a:off x="6428232" y="4846320"/>
+            <a:ext cx="5029200" cy="365760"/>
+          </a:xfrm>
+          <a:prstGeom prst="rect">
+            <a:avLst/>
+          </a:prstGeom>
+          <a:noFill/>
+          <a:ln/>
+        </p:spPr>
+        <p:txBody>
+          <a:bodyPr wrap="square" lIns="0" tIns="0" rIns="0" bIns="0" rtlCol="0" anchor="ctr"/>
+          <a:lstStyle/>
+          <a:p>
+            <a:pPr indent="0" marL="0">
+              <a:buNone/>
+            </a:pPr>
+            <a:r>
+              <a:rPr lang="en-US" sz="1200" b="1" dirty="0">
+                <a:solidFill>
+                  <a:srgbClr val="F2D8A0"/>
+                </a:solidFill>
+                <a:latin typeface="Microsoft YaHei" pitchFamily="34" charset="0"/>
+                <a:ea typeface="Microsoft YaHei" pitchFamily="34" charset="-122"/>
+                <a:cs typeface="Microsoft YaHei" pitchFamily="34" charset="-120"/>
+              </a:rPr>
+              <a:t>缺陷的共同特征：失败被吞掉，代码却仍做出“成功”的承诺</a:t>
+            </a:r>
+            <a:endParaRPr lang="en-US" sz="1200" dirty="0"/>
+          </a:p>
+        </p:txBody>
+      </p:sp>
+      <p:sp>
+        <p:nvSpPr>
+          <p:cNvPr id="33" name="Shape 31"/>
+          <p:cNvSpPr/>
+          <p:nvPr/>
+        </p:nvSpPr>
+        <p:spPr>
+          <a:xfrm>
+            <a:off x="6428232" y="5340096"/>
+            <a:ext cx="100584" cy="100584"/>
+          </a:xfrm>
+          <a:prstGeom prst="rect">
+            <a:avLst/>
+          </a:prstGeom>
+          <a:solidFill>
+            <a:srgbClr val="9E2B25"/>
+          </a:solidFill>
+          <a:ln/>
+        </p:spPr>
+      </p:sp>
+      <p:sp>
+        <p:nvSpPr>
+          <p:cNvPr id="34" name="Text 32"/>
+          <p:cNvSpPr/>
+          <p:nvPr/>
+        </p:nvSpPr>
+        <p:spPr>
+          <a:xfrm>
+            <a:off x="6665976" y="5257800"/>
+            <a:ext cx="4791456" cy="457200"/>
+          </a:xfrm>
+          <a:prstGeom prst="rect">
+            <a:avLst/>
+          </a:prstGeom>
+          <a:noFill/>
+          <a:ln/>
+        </p:spPr>
+        <p:txBody>
+          <a:bodyPr wrap="square" lIns="0" tIns="0" rIns="0" bIns="0" rtlCol="0" anchor="t"/>
+          <a:lstStyle/>
+          <a:p>
+            <a:pPr indent="0" marL="0">
+              <a:lnSpc>
+                <a:spcPct val="112000"/>
+              </a:lnSpc>
+              <a:buNone/>
+            </a:pPr>
+            <a:r>
+              <a:rPr lang="en-US" sz="1250" b="1" dirty="0">
+                <a:solidFill>
+                  <a:srgbClr val="EFE7DE"/>
+                </a:solidFill>
+                <a:latin typeface="Microsoft YaHei" pitchFamily="34" charset="0"/>
+                <a:ea typeface="Microsoft YaHei" pitchFamily="34" charset="-122"/>
+                <a:cs typeface="Microsoft YaHei" pitchFamily="34" charset="-120"/>
+              </a:rPr>
+              <a:t>隐私</a:t>
+            </a:r>
+            <a:pPr indent="0" marL="0">
+              <a:lnSpc>
+                <a:spcPct val="112000"/>
+              </a:lnSpc>
+              <a:buNone/>
+            </a:pPr>
+            <a:r>
+              <a:rPr lang="en-US" sz="1100" dirty="0">
+                <a:solidFill>
+                  <a:srgbClr val="A99C90"/>
+                </a:solidFill>
+                <a:latin typeface="Microsoft YaHei" pitchFamily="34" charset="0"/>
+                <a:ea typeface="Microsoft YaHei" pitchFamily="34" charset="-122"/>
+                <a:cs typeface="Microsoft YaHei" pitchFamily="34" charset="-120"/>
+              </a:rPr>
+              <a:t>　诊断包与日志确保不含公文正文（原 redact 护栏形同虚设）</a:t>
+            </a:r>
+            <a:endParaRPr lang="en-US" sz="1250" dirty="0"/>
+          </a:p>
+        </p:txBody>
+      </p:sp>
+      <p:sp>
+        <p:nvSpPr>
+          <p:cNvPr id="35" name="Shape 33"/>
+          <p:cNvSpPr/>
+          <p:nvPr/>
+        </p:nvSpPr>
+        <p:spPr>
+          <a:xfrm>
+            <a:off x="6428232" y="5843016"/>
+            <a:ext cx="100584" cy="100584"/>
+          </a:xfrm>
+          <a:prstGeom prst="rect">
+            <a:avLst/>
+          </a:prstGeom>
+          <a:solidFill>
+            <a:srgbClr val="9E2B25"/>
+          </a:solidFill>
+          <a:ln/>
+        </p:spPr>
+      </p:sp>
+      <p:sp>
+        <p:nvSpPr>
+          <p:cNvPr id="36" name="Text 34"/>
+          <p:cNvSpPr/>
+          <p:nvPr/>
+        </p:nvSpPr>
+        <p:spPr>
+          <a:xfrm>
+            <a:off x="6665976" y="5760720"/>
+            <a:ext cx="4791456" cy="457200"/>
+          </a:xfrm>
+          <a:prstGeom prst="rect">
+            <a:avLst/>
+          </a:prstGeom>
+          <a:noFill/>
+          <a:ln/>
+        </p:spPr>
+        <p:txBody>
+          <a:bodyPr wrap="square" lIns="0" tIns="0" rIns="0" bIns="0" rtlCol="0" anchor="t"/>
+          <a:lstStyle/>
+          <a:p>
+            <a:pPr indent="0" marL="0">
+              <a:lnSpc>
+                <a:spcPct val="112000"/>
+              </a:lnSpc>
+              <a:buNone/>
+            </a:pPr>
+            <a:r>
+              <a:rPr lang="en-US" sz="1250" b="1" dirty="0">
+                <a:solidFill>
+                  <a:srgbClr val="EFE7DE"/>
+                </a:solidFill>
+                <a:latin typeface="Microsoft YaHei" pitchFamily="34" charset="0"/>
+                <a:ea typeface="Microsoft YaHei" pitchFamily="34" charset="-122"/>
+                <a:cs typeface="Microsoft YaHei" pitchFamily="34" charset="-120"/>
+              </a:rPr>
+              <a:t>可见</a:t>
+            </a:r>
+            <a:pPr indent="0" marL="0">
+              <a:lnSpc>
+                <a:spcPct val="112000"/>
+              </a:lnSpc>
+              <a:buNone/>
+            </a:pPr>
+            <a:r>
+              <a:rPr lang="en-US" sz="1100" dirty="0">
+                <a:solidFill>
+                  <a:srgbClr val="A99C90"/>
+                </a:solidFill>
+                <a:latin typeface="Microsoft YaHei" pitchFamily="34" charset="0"/>
+                <a:ea typeface="Microsoft YaHei" pitchFamily="34" charset="-122"/>
+                <a:cs typeface="Microsoft YaHei" pitchFamily="34" charset="-120"/>
+              </a:rPr>
+              <a:t>　恢复失败/降级如实点名，不再一律说“成功”</a:t>
+            </a:r>
+            <a:endParaRPr lang="en-US" sz="1250" dirty="0"/>
+          </a:p>
+        </p:txBody>
+      </p:sp>
+    </p:spTree>
+  </p:cSld>
+  <p:clrMapOvr>
+    <a:masterClrMapping/>
+  </p:clrMapOvr>
+</p:sld>
+</file>
+
+<file path=ppt/slides/slide43.xml><?xml version="1.0" encoding="utf-8"?>
+<p:sld xmlns:a="http://schemas.openxmlformats.org/drawingml/2006/main" xmlns:r="http://schemas.openxmlformats.org/officeDocument/2006/relationships" xmlns:p="http://schemas.openxmlformats.org/presentationml/2006/main">
+  <p:cSld name="Slide 43">
+    <p:bg>
+      <p:bgPr>
+        <a:solidFill>
           <a:srgbClr val="1F1917"/>
         </a:solidFill>
       </p:bgPr>
@@ -40449,7 +42861,7 @@
                 <a:ea typeface="Microsoft YaHei" pitchFamily="34" charset="-122"/>
                 <a:cs typeface="Microsoft YaHei" pitchFamily="34" charset="-120"/>
               </a:rPr>
-              <a:t>scripts/e2e_check.py</a:t>
+              <a:t>open-code-review审查报告.md</a:t>
             </a:r>
             <a:endParaRPr lang="en-US" sz="1400" dirty="0"/>
           </a:p>
@@ -40469,7 +42881,7 @@
                 <a:ea typeface="Microsoft YaHei" pitchFamily="34" charset="-122"/>
                 <a:cs typeface="Microsoft YaHei" pitchFamily="34" charset="-120"/>
               </a:rPr>
-              <a:t>20 步端到端自检，部署后一键验货</a:t>
+              <a:t>全项目代码审查：范围、逐条真伪甄别、修复与验证</a:t>
             </a:r>
             <a:endParaRPr lang="en-US" sz="1400" dirty="0"/>
           </a:p>
@@ -41161,7 +43573,7 @@
                 <a:ea typeface="Microsoft YaHei" pitchFamily="34" charset="-122"/>
                 <a:cs typeface="Microsoft YaHei" pitchFamily="34" charset="-120"/>
               </a:rPr>
-              <a:t>15</a:t>
+              <a:t>12</a:t>
             </a:r>
             <a:endParaRPr lang="en-US" sz="4400" dirty="0"/>
           </a:p>
@@ -41203,7 +43615,7 @@
                 <a:ea typeface="Microsoft YaHei" pitchFamily="34" charset="-122"/>
                 <a:cs typeface="Microsoft YaHei" pitchFamily="34" charset="-120"/>
               </a:rPr>
-              <a:t>法定文种骨架</a:t>
+              <a:t>军队公文文种</a:t>
             </a:r>
             <a:endParaRPr lang="en-US" sz="1400" dirty="0"/>
           </a:p>
@@ -41223,7 +43635,7 @@
                 <a:ea typeface="Microsoft YaHei" pitchFamily="34" charset="-122"/>
                 <a:cs typeface="Microsoft YaHei" pitchFamily="34" charset="-120"/>
               </a:rPr>
-              <a:t>对应《公文处理工作条例》</a:t>
+              <a:t>对应《军队机关公文处理工作条例》第八条</a:t>
             </a:r>
             <a:endParaRPr lang="en-US" sz="1400" dirty="0"/>
           </a:p>
@@ -42379,7 +44791,7 @@
                 <a:ea typeface="Microsoft YaHei" pitchFamily="34" charset="-122"/>
                 <a:cs typeface="Microsoft YaHei" pitchFamily="34" charset="-120"/>
               </a:rPr>
-              <a:t>15 文种骨架 · 文秘工具箱</a:t>
+              <a:t>12 文种骨架 · 文秘工具箱</a:t>
             </a:r>
             <a:endParaRPr lang="en-US" sz="1500" dirty="0"/>
           </a:p>
@@ -42488,7 +44900,7 @@
                 <a:ea typeface="Microsoft YaHei" pitchFamily="34" charset="-122"/>
                 <a:cs typeface="Microsoft YaHei" pitchFamily="34" charset="-120"/>
               </a:rPr>
-              <a:t>三级纠错流水线 · GB/T 9704 体检</a:t>
+              <a:t>三级纠错流水线 · 军队公文格式体检</a:t>
             </a:r>
             <a:endParaRPr lang="en-US" sz="1500" dirty="0"/>
           </a:p>

</xml_diff>